<commit_message>
feat(p03): add 23 standalone runnable Flutter code examples and inject GitHub links into PPTX slides
</commit_message>
<xml_diff>
--- a/03_slide_presentasi/PERTEMUAN_03_Widget_Tree_dan_Layouting.pptx
+++ b/03_slide_presentasi/PERTEMUAN_03_Widget_Tree_dan_Layouting.pptx
@@ -3916,8 +3916,8 @@
         </p:nvSpPr>
         <p:spPr>
           <a:xfrm>
-            <a:off x="5669280" y="2176272"/>
-            <a:ext cx="5486400" cy="3977639"/>
+            <a:off x="5669280" y="2121408"/>
+            <a:ext cx="5486400" cy="3364992"/>
           </a:xfrm>
           <a:prstGeom prst="rect">
             <a:avLst/>
@@ -3931,7 +3931,7 @@
           <a:lstStyle/>
           <a:p>
             <a:pPr>
-              <a:defRPr sz="980">
+              <a:defRPr sz="919">
                 <a:solidFill>
                   <a:srgbClr val="F5F5F5"/>
                 </a:solidFill>
@@ -3993,6 +3993,142 @@
             <a:br/>
             <a:r>
               <a:t>);</a:t>
+            </a:r>
+          </a:p>
+        </p:txBody>
+      </p:sp>
+      <p:sp>
+        <p:nvSpPr>
+          <p:cNvPr id="15" name="Rectangle 14"/>
+          <p:cNvSpPr/>
+          <p:nvPr/>
+        </p:nvSpPr>
+        <p:spPr>
+          <a:xfrm>
+            <a:off x="5660136" y="5669280"/>
+            <a:ext cx="5608015" cy="548640"/>
+          </a:xfrm>
+          <a:prstGeom prst="rect">
+            <a:avLst/>
+          </a:prstGeom>
+          <a:solidFill>
+            <a:srgbClr val="000000"/>
+          </a:solidFill>
+          <a:ln>
+            <a:noFill/>
+          </a:ln>
+        </p:spPr>
+        <p:style>
+          <a:lnRef idx="1">
+            <a:schemeClr val="accent1"/>
+          </a:lnRef>
+          <a:fillRef idx="3">
+            <a:schemeClr val="accent1"/>
+          </a:fillRef>
+          <a:effectRef idx="2">
+            <a:schemeClr val="accent1"/>
+          </a:effectRef>
+          <a:fontRef idx="minor">
+            <a:schemeClr val="lt1"/>
+          </a:fontRef>
+        </p:style>
+        <p:txBody>
+          <a:bodyPr rtlCol="0" anchor="ctr"/>
+          <a:lstStyle/>
+          <a:p>
+            <a:pPr algn="ctr"/>
+          </a:p>
+        </p:txBody>
+      </p:sp>
+      <p:sp>
+        <p:nvSpPr>
+          <p:cNvPr id="16" name="Rectangle 15"/>
+          <p:cNvSpPr/>
+          <p:nvPr/>
+        </p:nvSpPr>
+        <p:spPr>
+          <a:xfrm>
+            <a:off x="5623560" y="5632704"/>
+            <a:ext cx="5608015" cy="548640"/>
+          </a:xfrm>
+          <a:prstGeom prst="rect">
+            <a:avLst/>
+          </a:prstGeom>
+          <a:solidFill>
+            <a:srgbClr val="FFE600"/>
+          </a:solidFill>
+          <a:ln w="25400">
+            <a:solidFill>
+              <a:srgbClr val="000000"/>
+            </a:solidFill>
+          </a:ln>
+        </p:spPr>
+        <p:style>
+          <a:lnRef idx="1">
+            <a:schemeClr val="accent1"/>
+          </a:lnRef>
+          <a:fillRef idx="3">
+            <a:schemeClr val="accent1"/>
+          </a:fillRef>
+          <a:effectRef idx="2">
+            <a:schemeClr val="accent1"/>
+          </a:effectRef>
+          <a:fontRef idx="minor">
+            <a:schemeClr val="lt1"/>
+          </a:fontRef>
+        </p:style>
+        <p:txBody>
+          <a:bodyPr rtlCol="0" anchor="ctr"/>
+          <a:lstStyle/>
+          <a:p>
+            <a:pPr algn="ctr"/>
+          </a:p>
+        </p:txBody>
+      </p:sp>
+      <p:sp>
+        <p:nvSpPr>
+          <p:cNvPr id="17" name="TextBox 16"/>
+          <p:cNvSpPr txBox="1"/>
+          <p:nvPr/>
+        </p:nvSpPr>
+        <p:spPr>
+          <a:xfrm>
+            <a:off x="5696712" y="5660136"/>
+            <a:ext cx="5461711" cy="493776"/>
+          </a:xfrm>
+          <a:prstGeom prst="rect">
+            <a:avLst/>
+          </a:prstGeom>
+          <a:noFill/>
+        </p:spPr>
+        <p:txBody>
+          <a:bodyPr wrap="square">
+            <a:spAutoFit/>
+          </a:bodyPr>
+          <a:lstStyle/>
+          <a:p>
+            <a:r>
+              <a:rPr sz="960" b="1">
+                <a:solidFill>
+                  <a:srgbClr val="000000"/>
+                </a:solidFill>
+                <a:latin typeface="Segoe UI"/>
+                <a:hlinkClick r:id="rId2"/>
+              </a:rPr>
+              <a:t>▶ BUKA KODE LENGKAP DI GITHUB (slide_10_single_child_layout.dart)</a:t>
+            </a:r>
+          </a:p>
+          <a:p>
+            <a:pPr>
+              <a:defRPr sz="760">
+                <a:solidFill>
+                  <a:srgbClr val="3C3C3C"/>
+                </a:solidFill>
+                <a:latin typeface="Segoe UI"/>
+              </a:defRPr>
+            </a:pPr>
+            <a:r>
+              <a:t>💡 Buka di browser / salin source code: github.com/antonprafanto/mobile2026</a:t>
             </a:r>
           </a:p>
         </p:txBody>
@@ -4583,8 +4719,8 @@
         </p:nvSpPr>
         <p:spPr>
           <a:xfrm>
-            <a:off x="5669280" y="2176272"/>
-            <a:ext cx="5486400" cy="3977639"/>
+            <a:off x="5669280" y="2121408"/>
+            <a:ext cx="5486400" cy="3364992"/>
           </a:xfrm>
           <a:prstGeom prst="rect">
             <a:avLst/>
@@ -4598,7 +4734,7 @@
           <a:lstStyle/>
           <a:p>
             <a:pPr>
-              <a:defRPr sz="980">
+              <a:defRPr sz="919">
                 <a:solidFill>
                   <a:srgbClr val="F5F5F5"/>
                 </a:solidFill>
@@ -4660,6 +4796,142 @@
             <a:br/>
             <a:r>
               <a:t>)</a:t>
+            </a:r>
+          </a:p>
+        </p:txBody>
+      </p:sp>
+      <p:sp>
+        <p:nvSpPr>
+          <p:cNvPr id="15" name="Rectangle 14"/>
+          <p:cNvSpPr/>
+          <p:nvPr/>
+        </p:nvSpPr>
+        <p:spPr>
+          <a:xfrm>
+            <a:off x="5660136" y="5669280"/>
+            <a:ext cx="5608015" cy="548640"/>
+          </a:xfrm>
+          <a:prstGeom prst="rect">
+            <a:avLst/>
+          </a:prstGeom>
+          <a:solidFill>
+            <a:srgbClr val="000000"/>
+          </a:solidFill>
+          <a:ln>
+            <a:noFill/>
+          </a:ln>
+        </p:spPr>
+        <p:style>
+          <a:lnRef idx="1">
+            <a:schemeClr val="accent1"/>
+          </a:lnRef>
+          <a:fillRef idx="3">
+            <a:schemeClr val="accent1"/>
+          </a:fillRef>
+          <a:effectRef idx="2">
+            <a:schemeClr val="accent1"/>
+          </a:effectRef>
+          <a:fontRef idx="minor">
+            <a:schemeClr val="lt1"/>
+          </a:fontRef>
+        </p:style>
+        <p:txBody>
+          <a:bodyPr rtlCol="0" anchor="ctr"/>
+          <a:lstStyle/>
+          <a:p>
+            <a:pPr algn="ctr"/>
+          </a:p>
+        </p:txBody>
+      </p:sp>
+      <p:sp>
+        <p:nvSpPr>
+          <p:cNvPr id="16" name="Rectangle 15"/>
+          <p:cNvSpPr/>
+          <p:nvPr/>
+        </p:nvSpPr>
+        <p:spPr>
+          <a:xfrm>
+            <a:off x="5623560" y="5632704"/>
+            <a:ext cx="5608015" cy="548640"/>
+          </a:xfrm>
+          <a:prstGeom prst="rect">
+            <a:avLst/>
+          </a:prstGeom>
+          <a:solidFill>
+            <a:srgbClr val="FFE600"/>
+          </a:solidFill>
+          <a:ln w="25400">
+            <a:solidFill>
+              <a:srgbClr val="000000"/>
+            </a:solidFill>
+          </a:ln>
+        </p:spPr>
+        <p:style>
+          <a:lnRef idx="1">
+            <a:schemeClr val="accent1"/>
+          </a:lnRef>
+          <a:fillRef idx="3">
+            <a:schemeClr val="accent1"/>
+          </a:fillRef>
+          <a:effectRef idx="2">
+            <a:schemeClr val="accent1"/>
+          </a:effectRef>
+          <a:fontRef idx="minor">
+            <a:schemeClr val="lt1"/>
+          </a:fontRef>
+        </p:style>
+        <p:txBody>
+          <a:bodyPr rtlCol="0" anchor="ctr"/>
+          <a:lstStyle/>
+          <a:p>
+            <a:pPr algn="ctr"/>
+          </a:p>
+        </p:txBody>
+      </p:sp>
+      <p:sp>
+        <p:nvSpPr>
+          <p:cNvPr id="17" name="TextBox 16"/>
+          <p:cNvSpPr txBox="1"/>
+          <p:nvPr/>
+        </p:nvSpPr>
+        <p:spPr>
+          <a:xfrm>
+            <a:off x="5696712" y="5660136"/>
+            <a:ext cx="5461711" cy="493776"/>
+          </a:xfrm>
+          <a:prstGeom prst="rect">
+            <a:avLst/>
+          </a:prstGeom>
+          <a:noFill/>
+        </p:spPr>
+        <p:txBody>
+          <a:bodyPr wrap="square">
+            <a:spAutoFit/>
+          </a:bodyPr>
+          <a:lstStyle/>
+          <a:p>
+            <a:r>
+              <a:rPr sz="960" b="1">
+                <a:solidFill>
+                  <a:srgbClr val="000000"/>
+                </a:solidFill>
+                <a:latin typeface="Segoe UI"/>
+                <a:hlinkClick r:id="rId2"/>
+              </a:rPr>
+              <a:t>▶ BUKA KODE LENGKAP DI GITHUB (slide_11_jebakan_color_vs_decoration.dart)</a:t>
+            </a:r>
+          </a:p>
+          <a:p>
+            <a:pPr>
+              <a:defRPr sz="760">
+                <a:solidFill>
+                  <a:srgbClr val="3C3C3C"/>
+                </a:solidFill>
+                <a:latin typeface="Segoe UI"/>
+              </a:defRPr>
+            </a:pPr>
+            <a:r>
+              <a:t>💡 Buka di browser / salin source code: github.com/antonprafanto/mobile2026</a:t>
             </a:r>
           </a:p>
         </p:txBody>
@@ -5266,8 +5538,8 @@
         </p:nvSpPr>
         <p:spPr>
           <a:xfrm>
-            <a:off x="5669280" y="2176272"/>
-            <a:ext cx="5486400" cy="3977639"/>
+            <a:off x="5669280" y="2121408"/>
+            <a:ext cx="5486400" cy="3364992"/>
           </a:xfrm>
           <a:prstGeom prst="rect">
             <a:avLst/>
@@ -5281,7 +5553,7 @@
           <a:lstStyle/>
           <a:p>
             <a:pPr>
-              <a:defRPr sz="980">
+              <a:defRPr sz="919">
                 <a:solidFill>
                   <a:srgbClr val="F5F5F5"/>
                 </a:solidFill>
@@ -5326,6 +5598,142 @@
             <a:br/>
             <a:r>
               <a:t>)</a:t>
+            </a:r>
+          </a:p>
+        </p:txBody>
+      </p:sp>
+      <p:sp>
+        <p:nvSpPr>
+          <p:cNvPr id="15" name="Rectangle 14"/>
+          <p:cNvSpPr/>
+          <p:nvPr/>
+        </p:nvSpPr>
+        <p:spPr>
+          <a:xfrm>
+            <a:off x="5660136" y="5669280"/>
+            <a:ext cx="5608015" cy="548640"/>
+          </a:xfrm>
+          <a:prstGeom prst="rect">
+            <a:avLst/>
+          </a:prstGeom>
+          <a:solidFill>
+            <a:srgbClr val="000000"/>
+          </a:solidFill>
+          <a:ln>
+            <a:noFill/>
+          </a:ln>
+        </p:spPr>
+        <p:style>
+          <a:lnRef idx="1">
+            <a:schemeClr val="accent1"/>
+          </a:lnRef>
+          <a:fillRef idx="3">
+            <a:schemeClr val="accent1"/>
+          </a:fillRef>
+          <a:effectRef idx="2">
+            <a:schemeClr val="accent1"/>
+          </a:effectRef>
+          <a:fontRef idx="minor">
+            <a:schemeClr val="lt1"/>
+          </a:fontRef>
+        </p:style>
+        <p:txBody>
+          <a:bodyPr rtlCol="0" anchor="ctr"/>
+          <a:lstStyle/>
+          <a:p>
+            <a:pPr algn="ctr"/>
+          </a:p>
+        </p:txBody>
+      </p:sp>
+      <p:sp>
+        <p:nvSpPr>
+          <p:cNvPr id="16" name="Rectangle 15"/>
+          <p:cNvSpPr/>
+          <p:nvPr/>
+        </p:nvSpPr>
+        <p:spPr>
+          <a:xfrm>
+            <a:off x="5623560" y="5632704"/>
+            <a:ext cx="5608015" cy="548640"/>
+          </a:xfrm>
+          <a:prstGeom prst="rect">
+            <a:avLst/>
+          </a:prstGeom>
+          <a:solidFill>
+            <a:srgbClr val="FFE600"/>
+          </a:solidFill>
+          <a:ln w="25400">
+            <a:solidFill>
+              <a:srgbClr val="000000"/>
+            </a:solidFill>
+          </a:ln>
+        </p:spPr>
+        <p:style>
+          <a:lnRef idx="1">
+            <a:schemeClr val="accent1"/>
+          </a:lnRef>
+          <a:fillRef idx="3">
+            <a:schemeClr val="accent1"/>
+          </a:fillRef>
+          <a:effectRef idx="2">
+            <a:schemeClr val="accent1"/>
+          </a:effectRef>
+          <a:fontRef idx="minor">
+            <a:schemeClr val="lt1"/>
+          </a:fontRef>
+        </p:style>
+        <p:txBody>
+          <a:bodyPr rtlCol="0" anchor="ctr"/>
+          <a:lstStyle/>
+          <a:p>
+            <a:pPr algn="ctr"/>
+          </a:p>
+        </p:txBody>
+      </p:sp>
+      <p:sp>
+        <p:nvSpPr>
+          <p:cNvPr id="17" name="TextBox 16"/>
+          <p:cNvSpPr txBox="1"/>
+          <p:nvPr/>
+        </p:nvSpPr>
+        <p:spPr>
+          <a:xfrm>
+            <a:off x="5696712" y="5660136"/>
+            <a:ext cx="5461711" cy="493776"/>
+          </a:xfrm>
+          <a:prstGeom prst="rect">
+            <a:avLst/>
+          </a:prstGeom>
+          <a:noFill/>
+        </p:spPr>
+        <p:txBody>
+          <a:bodyPr wrap="square">
+            <a:spAutoFit/>
+          </a:bodyPr>
+          <a:lstStyle/>
+          <a:p>
+            <a:r>
+              <a:rPr sz="960" b="1">
+                <a:solidFill>
+                  <a:srgbClr val="000000"/>
+                </a:solidFill>
+                <a:latin typeface="Segoe UI"/>
+                <a:hlinkClick r:id="rId2"/>
+              </a:rPr>
+              <a:t>▶ BUKA KODE LENGKAP DI GITHUB (slide_12_multi_child_row_column.dart)</a:t>
+            </a:r>
+          </a:p>
+          <a:p>
+            <a:pPr>
+              <a:defRPr sz="760">
+                <a:solidFill>
+                  <a:srgbClr val="3C3C3C"/>
+                </a:solidFill>
+                <a:latin typeface="Segoe UI"/>
+              </a:defRPr>
+            </a:pPr>
+            <a:r>
+              <a:t>💡 Buka di browser / salin source code: github.com/antonprafanto/mobile2026</a:t>
             </a:r>
           </a:p>
         </p:txBody>
@@ -5916,8 +6324,8 @@
         </p:nvSpPr>
         <p:spPr>
           <a:xfrm>
-            <a:off x="5669280" y="2176272"/>
-            <a:ext cx="5486400" cy="3977639"/>
+            <a:off x="5669280" y="2121408"/>
+            <a:ext cx="5486400" cy="3364992"/>
           </a:xfrm>
           <a:prstGeom prst="rect">
             <a:avLst/>
@@ -5931,7 +6339,7 @@
           <a:lstStyle/>
           <a:p>
             <a:pPr>
-              <a:defRPr sz="980">
+              <a:defRPr sz="919">
                 <a:solidFill>
                   <a:srgbClr val="F5F5F5"/>
                 </a:solidFill>
@@ -5972,6 +6380,142 @@
             <a:br/>
             <a:r>
               <a:t>)</a:t>
+            </a:r>
+          </a:p>
+        </p:txBody>
+      </p:sp>
+      <p:sp>
+        <p:nvSpPr>
+          <p:cNvPr id="15" name="Rectangle 14"/>
+          <p:cNvSpPr/>
+          <p:nvPr/>
+        </p:nvSpPr>
+        <p:spPr>
+          <a:xfrm>
+            <a:off x="5660136" y="5669280"/>
+            <a:ext cx="5608015" cy="548640"/>
+          </a:xfrm>
+          <a:prstGeom prst="rect">
+            <a:avLst/>
+          </a:prstGeom>
+          <a:solidFill>
+            <a:srgbClr val="000000"/>
+          </a:solidFill>
+          <a:ln>
+            <a:noFill/>
+          </a:ln>
+        </p:spPr>
+        <p:style>
+          <a:lnRef idx="1">
+            <a:schemeClr val="accent1"/>
+          </a:lnRef>
+          <a:fillRef idx="3">
+            <a:schemeClr val="accent1"/>
+          </a:fillRef>
+          <a:effectRef idx="2">
+            <a:schemeClr val="accent1"/>
+          </a:effectRef>
+          <a:fontRef idx="minor">
+            <a:schemeClr val="lt1"/>
+          </a:fontRef>
+        </p:style>
+        <p:txBody>
+          <a:bodyPr rtlCol="0" anchor="ctr"/>
+          <a:lstStyle/>
+          <a:p>
+            <a:pPr algn="ctr"/>
+          </a:p>
+        </p:txBody>
+      </p:sp>
+      <p:sp>
+        <p:nvSpPr>
+          <p:cNvPr id="16" name="Rectangle 15"/>
+          <p:cNvSpPr/>
+          <p:nvPr/>
+        </p:nvSpPr>
+        <p:spPr>
+          <a:xfrm>
+            <a:off x="5623560" y="5632704"/>
+            <a:ext cx="5608015" cy="548640"/>
+          </a:xfrm>
+          <a:prstGeom prst="rect">
+            <a:avLst/>
+          </a:prstGeom>
+          <a:solidFill>
+            <a:srgbClr val="FFE600"/>
+          </a:solidFill>
+          <a:ln w="25400">
+            <a:solidFill>
+              <a:srgbClr val="000000"/>
+            </a:solidFill>
+          </a:ln>
+        </p:spPr>
+        <p:style>
+          <a:lnRef idx="1">
+            <a:schemeClr val="accent1"/>
+          </a:lnRef>
+          <a:fillRef idx="3">
+            <a:schemeClr val="accent1"/>
+          </a:fillRef>
+          <a:effectRef idx="2">
+            <a:schemeClr val="accent1"/>
+          </a:effectRef>
+          <a:fontRef idx="minor">
+            <a:schemeClr val="lt1"/>
+          </a:fontRef>
+        </p:style>
+        <p:txBody>
+          <a:bodyPr rtlCol="0" anchor="ctr"/>
+          <a:lstStyle/>
+          <a:p>
+            <a:pPr algn="ctr"/>
+          </a:p>
+        </p:txBody>
+      </p:sp>
+      <p:sp>
+        <p:nvSpPr>
+          <p:cNvPr id="17" name="TextBox 16"/>
+          <p:cNvSpPr txBox="1"/>
+          <p:nvPr/>
+        </p:nvSpPr>
+        <p:spPr>
+          <a:xfrm>
+            <a:off x="5696712" y="5660136"/>
+            <a:ext cx="5461711" cy="493776"/>
+          </a:xfrm>
+          <a:prstGeom prst="rect">
+            <a:avLst/>
+          </a:prstGeom>
+          <a:noFill/>
+        </p:spPr>
+        <p:txBody>
+          <a:bodyPr wrap="square">
+            <a:spAutoFit/>
+          </a:bodyPr>
+          <a:lstStyle/>
+          <a:p>
+            <a:r>
+              <a:rPr sz="960" b="1">
+                <a:solidFill>
+                  <a:srgbClr val="000000"/>
+                </a:solidFill>
+                <a:latin typeface="Segoe UI"/>
+                <a:hlinkClick r:id="rId2"/>
+              </a:rPr>
+              <a:t>▶ BUKA KODE LENGKAP DI GITHUB (slide_13_trik_spasi_sizedbox_spacer.dart)</a:t>
+            </a:r>
+          </a:p>
+          <a:p>
+            <a:pPr>
+              <a:defRPr sz="760">
+                <a:solidFill>
+                  <a:srgbClr val="3C3C3C"/>
+                </a:solidFill>
+                <a:latin typeface="Segoe UI"/>
+              </a:defRPr>
+            </a:pPr>
+            <a:r>
+              <a:t>💡 Buka di browser / salin source code: github.com/antonprafanto/mobile2026</a:t>
             </a:r>
           </a:p>
         </p:txBody>
@@ -6578,8 +7122,8 @@
         </p:nvSpPr>
         <p:spPr>
           <a:xfrm>
-            <a:off x="5669280" y="2176272"/>
-            <a:ext cx="5486400" cy="3977639"/>
+            <a:off x="5669280" y="2121408"/>
+            <a:ext cx="5486400" cy="3364992"/>
           </a:xfrm>
           <a:prstGeom prst="rect">
             <a:avLst/>
@@ -6593,7 +7137,7 @@
           <a:lstStyle/>
           <a:p>
             <a:pPr>
-              <a:defRPr sz="980">
+              <a:defRPr sz="919">
                 <a:solidFill>
                   <a:srgbClr val="F5F5F5"/>
                 </a:solidFill>
@@ -6650,6 +7194,142 @@
             <a:br/>
             <a:r>
               <a:t>)</a:t>
+            </a:r>
+          </a:p>
+        </p:txBody>
+      </p:sp>
+      <p:sp>
+        <p:nvSpPr>
+          <p:cNvPr id="15" name="Rectangle 14"/>
+          <p:cNvSpPr/>
+          <p:nvPr/>
+        </p:nvSpPr>
+        <p:spPr>
+          <a:xfrm>
+            <a:off x="5660136" y="5669280"/>
+            <a:ext cx="5608015" cy="548640"/>
+          </a:xfrm>
+          <a:prstGeom prst="rect">
+            <a:avLst/>
+          </a:prstGeom>
+          <a:solidFill>
+            <a:srgbClr val="000000"/>
+          </a:solidFill>
+          <a:ln>
+            <a:noFill/>
+          </a:ln>
+        </p:spPr>
+        <p:style>
+          <a:lnRef idx="1">
+            <a:schemeClr val="accent1"/>
+          </a:lnRef>
+          <a:fillRef idx="3">
+            <a:schemeClr val="accent1"/>
+          </a:fillRef>
+          <a:effectRef idx="2">
+            <a:schemeClr val="accent1"/>
+          </a:effectRef>
+          <a:fontRef idx="minor">
+            <a:schemeClr val="lt1"/>
+          </a:fontRef>
+        </p:style>
+        <p:txBody>
+          <a:bodyPr rtlCol="0" anchor="ctr"/>
+          <a:lstStyle/>
+          <a:p>
+            <a:pPr algn="ctr"/>
+          </a:p>
+        </p:txBody>
+      </p:sp>
+      <p:sp>
+        <p:nvSpPr>
+          <p:cNvPr id="16" name="Rectangle 15"/>
+          <p:cNvSpPr/>
+          <p:nvPr/>
+        </p:nvSpPr>
+        <p:spPr>
+          <a:xfrm>
+            <a:off x="5623560" y="5632704"/>
+            <a:ext cx="5608015" cy="548640"/>
+          </a:xfrm>
+          <a:prstGeom prst="rect">
+            <a:avLst/>
+          </a:prstGeom>
+          <a:solidFill>
+            <a:srgbClr val="FFE600"/>
+          </a:solidFill>
+          <a:ln w="25400">
+            <a:solidFill>
+              <a:srgbClr val="000000"/>
+            </a:solidFill>
+          </a:ln>
+        </p:spPr>
+        <p:style>
+          <a:lnRef idx="1">
+            <a:schemeClr val="accent1"/>
+          </a:lnRef>
+          <a:fillRef idx="3">
+            <a:schemeClr val="accent1"/>
+          </a:fillRef>
+          <a:effectRef idx="2">
+            <a:schemeClr val="accent1"/>
+          </a:effectRef>
+          <a:fontRef idx="minor">
+            <a:schemeClr val="lt1"/>
+          </a:fontRef>
+        </p:style>
+        <p:txBody>
+          <a:bodyPr rtlCol="0" anchor="ctr"/>
+          <a:lstStyle/>
+          <a:p>
+            <a:pPr algn="ctr"/>
+          </a:p>
+        </p:txBody>
+      </p:sp>
+      <p:sp>
+        <p:nvSpPr>
+          <p:cNvPr id="17" name="TextBox 16"/>
+          <p:cNvSpPr txBox="1"/>
+          <p:nvPr/>
+        </p:nvSpPr>
+        <p:spPr>
+          <a:xfrm>
+            <a:off x="5696712" y="5660136"/>
+            <a:ext cx="5461711" cy="493776"/>
+          </a:xfrm>
+          <a:prstGeom prst="rect">
+            <a:avLst/>
+          </a:prstGeom>
+          <a:noFill/>
+        </p:spPr>
+        <p:txBody>
+          <a:bodyPr wrap="square">
+            <a:spAutoFit/>
+          </a:bodyPr>
+          <a:lstStyle/>
+          <a:p>
+            <a:r>
+              <a:rPr sz="960" b="1">
+                <a:solidFill>
+                  <a:srgbClr val="000000"/>
+                </a:solidFill>
+                <a:latin typeface="Segoe UI"/>
+                <a:hlinkClick r:id="rId2"/>
+              </a:rPr>
+              <a:t>▶ BUKA KODE LENGKAP DI GITHUB (slide_14_flexible_vs_expanded.dart)</a:t>
+            </a:r>
+          </a:p>
+          <a:p>
+            <a:pPr>
+              <a:defRPr sz="760">
+                <a:solidFill>
+                  <a:srgbClr val="3C3C3C"/>
+                </a:solidFill>
+                <a:latin typeface="Segoe UI"/>
+              </a:defRPr>
+            </a:pPr>
+            <a:r>
+              <a:t>💡 Buka di browser / salin source code: github.com/antonprafanto/mobile2026</a:t>
             </a:r>
           </a:p>
         </p:txBody>
@@ -7240,8 +7920,8 @@
         </p:nvSpPr>
         <p:spPr>
           <a:xfrm>
-            <a:off x="5669280" y="2176272"/>
-            <a:ext cx="5486400" cy="3977639"/>
+            <a:off x="5669280" y="2121408"/>
+            <a:ext cx="5486400" cy="3364992"/>
           </a:xfrm>
           <a:prstGeom prst="rect">
             <a:avLst/>
@@ -7255,7 +7935,7 @@
           <a:lstStyle/>
           <a:p>
             <a:pPr>
-              <a:defRPr sz="980">
+              <a:defRPr sz="919">
                 <a:solidFill>
                   <a:srgbClr val="F5F5F5"/>
                 </a:solidFill>
@@ -7324,6 +8004,142 @@
             <a:br/>
             <a:r>
               <a:t>)</a:t>
+            </a:r>
+          </a:p>
+        </p:txBody>
+      </p:sp>
+      <p:sp>
+        <p:nvSpPr>
+          <p:cNvPr id="15" name="Rectangle 14"/>
+          <p:cNvSpPr/>
+          <p:nvPr/>
+        </p:nvSpPr>
+        <p:spPr>
+          <a:xfrm>
+            <a:off x="5660136" y="5669280"/>
+            <a:ext cx="5608015" cy="548640"/>
+          </a:xfrm>
+          <a:prstGeom prst="rect">
+            <a:avLst/>
+          </a:prstGeom>
+          <a:solidFill>
+            <a:srgbClr val="000000"/>
+          </a:solidFill>
+          <a:ln>
+            <a:noFill/>
+          </a:ln>
+        </p:spPr>
+        <p:style>
+          <a:lnRef idx="1">
+            <a:schemeClr val="accent1"/>
+          </a:lnRef>
+          <a:fillRef idx="3">
+            <a:schemeClr val="accent1"/>
+          </a:fillRef>
+          <a:effectRef idx="2">
+            <a:schemeClr val="accent1"/>
+          </a:effectRef>
+          <a:fontRef idx="minor">
+            <a:schemeClr val="lt1"/>
+          </a:fontRef>
+        </p:style>
+        <p:txBody>
+          <a:bodyPr rtlCol="0" anchor="ctr"/>
+          <a:lstStyle/>
+          <a:p>
+            <a:pPr algn="ctr"/>
+          </a:p>
+        </p:txBody>
+      </p:sp>
+      <p:sp>
+        <p:nvSpPr>
+          <p:cNvPr id="16" name="Rectangle 15"/>
+          <p:cNvSpPr/>
+          <p:nvPr/>
+        </p:nvSpPr>
+        <p:spPr>
+          <a:xfrm>
+            <a:off x="5623560" y="5632704"/>
+            <a:ext cx="5608015" cy="548640"/>
+          </a:xfrm>
+          <a:prstGeom prst="rect">
+            <a:avLst/>
+          </a:prstGeom>
+          <a:solidFill>
+            <a:srgbClr val="FFE600"/>
+          </a:solidFill>
+          <a:ln w="25400">
+            <a:solidFill>
+              <a:srgbClr val="000000"/>
+            </a:solidFill>
+          </a:ln>
+        </p:spPr>
+        <p:style>
+          <a:lnRef idx="1">
+            <a:schemeClr val="accent1"/>
+          </a:lnRef>
+          <a:fillRef idx="3">
+            <a:schemeClr val="accent1"/>
+          </a:fillRef>
+          <a:effectRef idx="2">
+            <a:schemeClr val="accent1"/>
+          </a:effectRef>
+          <a:fontRef idx="minor">
+            <a:schemeClr val="lt1"/>
+          </a:fontRef>
+        </p:style>
+        <p:txBody>
+          <a:bodyPr rtlCol="0" anchor="ctr"/>
+          <a:lstStyle/>
+          <a:p>
+            <a:pPr algn="ctr"/>
+          </a:p>
+        </p:txBody>
+      </p:sp>
+      <p:sp>
+        <p:nvSpPr>
+          <p:cNvPr id="17" name="TextBox 16"/>
+          <p:cNvSpPr txBox="1"/>
+          <p:nvPr/>
+        </p:nvSpPr>
+        <p:spPr>
+          <a:xfrm>
+            <a:off x="5696712" y="5660136"/>
+            <a:ext cx="5461711" cy="493776"/>
+          </a:xfrm>
+          <a:prstGeom prst="rect">
+            <a:avLst/>
+          </a:prstGeom>
+          <a:noFill/>
+        </p:spPr>
+        <p:txBody>
+          <a:bodyPr wrap="square">
+            <a:spAutoFit/>
+          </a:bodyPr>
+          <a:lstStyle/>
+          <a:p>
+            <a:r>
+              <a:rPr sz="960" b="1">
+                <a:solidFill>
+                  <a:srgbClr val="000000"/>
+                </a:solidFill>
+                <a:latin typeface="Segoe UI"/>
+                <a:hlinkClick r:id="rId2"/>
+              </a:rPr>
+              <a:t>▶ BUKA KODE LENGKAP DI GITHUB (slide_15_layout_menumpuk_stack.dart)</a:t>
+            </a:r>
+          </a:p>
+          <a:p>
+            <a:pPr>
+              <a:defRPr sz="760">
+                <a:solidFill>
+                  <a:srgbClr val="3C3C3C"/>
+                </a:solidFill>
+                <a:latin typeface="Segoe UI"/>
+              </a:defRPr>
+            </a:pPr>
+            <a:r>
+              <a:t>💡 Buka di browser / salin source code: github.com/antonprafanto/mobile2026</a:t>
             </a:r>
           </a:p>
         </p:txBody>
@@ -7930,8 +8746,8 @@
         </p:nvSpPr>
         <p:spPr>
           <a:xfrm>
-            <a:off x="5669280" y="2176272"/>
-            <a:ext cx="5486400" cy="3977639"/>
+            <a:off x="5669280" y="2121408"/>
+            <a:ext cx="5486400" cy="3364992"/>
           </a:xfrm>
           <a:prstGeom prst="rect">
             <a:avLst/>
@@ -7945,7 +8761,7 @@
           <a:lstStyle/>
           <a:p>
             <a:pPr>
-              <a:defRPr sz="980">
+              <a:defRPr sz="919">
                 <a:solidFill>
                   <a:srgbClr val="F5F5F5"/>
                 </a:solidFill>
@@ -7994,6 +8810,142 @@
             <a:br/>
             <a:r>
               <a:t>)</a:t>
+            </a:r>
+          </a:p>
+        </p:txBody>
+      </p:sp>
+      <p:sp>
+        <p:nvSpPr>
+          <p:cNvPr id="15" name="Rectangle 14"/>
+          <p:cNvSpPr/>
+          <p:nvPr/>
+        </p:nvSpPr>
+        <p:spPr>
+          <a:xfrm>
+            <a:off x="5660136" y="5669280"/>
+            <a:ext cx="5608015" cy="548640"/>
+          </a:xfrm>
+          <a:prstGeom prst="rect">
+            <a:avLst/>
+          </a:prstGeom>
+          <a:solidFill>
+            <a:srgbClr val="000000"/>
+          </a:solidFill>
+          <a:ln>
+            <a:noFill/>
+          </a:ln>
+        </p:spPr>
+        <p:style>
+          <a:lnRef idx="1">
+            <a:schemeClr val="accent1"/>
+          </a:lnRef>
+          <a:fillRef idx="3">
+            <a:schemeClr val="accent1"/>
+          </a:fillRef>
+          <a:effectRef idx="2">
+            <a:schemeClr val="accent1"/>
+          </a:effectRef>
+          <a:fontRef idx="minor">
+            <a:schemeClr val="lt1"/>
+          </a:fontRef>
+        </p:style>
+        <p:txBody>
+          <a:bodyPr rtlCol="0" anchor="ctr"/>
+          <a:lstStyle/>
+          <a:p>
+            <a:pPr algn="ctr"/>
+          </a:p>
+        </p:txBody>
+      </p:sp>
+      <p:sp>
+        <p:nvSpPr>
+          <p:cNvPr id="16" name="Rectangle 15"/>
+          <p:cNvSpPr/>
+          <p:nvPr/>
+        </p:nvSpPr>
+        <p:spPr>
+          <a:xfrm>
+            <a:off x="5623560" y="5632704"/>
+            <a:ext cx="5608015" cy="548640"/>
+          </a:xfrm>
+          <a:prstGeom prst="rect">
+            <a:avLst/>
+          </a:prstGeom>
+          <a:solidFill>
+            <a:srgbClr val="FFE600"/>
+          </a:solidFill>
+          <a:ln w="25400">
+            <a:solidFill>
+              <a:srgbClr val="000000"/>
+            </a:solidFill>
+          </a:ln>
+        </p:spPr>
+        <p:style>
+          <a:lnRef idx="1">
+            <a:schemeClr val="accent1"/>
+          </a:lnRef>
+          <a:fillRef idx="3">
+            <a:schemeClr val="accent1"/>
+          </a:fillRef>
+          <a:effectRef idx="2">
+            <a:schemeClr val="accent1"/>
+          </a:effectRef>
+          <a:fontRef idx="minor">
+            <a:schemeClr val="lt1"/>
+          </a:fontRef>
+        </p:style>
+        <p:txBody>
+          <a:bodyPr rtlCol="0" anchor="ctr"/>
+          <a:lstStyle/>
+          <a:p>
+            <a:pPr algn="ctr"/>
+          </a:p>
+        </p:txBody>
+      </p:sp>
+      <p:sp>
+        <p:nvSpPr>
+          <p:cNvPr id="17" name="TextBox 16"/>
+          <p:cNvSpPr txBox="1"/>
+          <p:nvPr/>
+        </p:nvSpPr>
+        <p:spPr>
+          <a:xfrm>
+            <a:off x="5696712" y="5660136"/>
+            <a:ext cx="5461711" cy="493776"/>
+          </a:xfrm>
+          <a:prstGeom prst="rect">
+            <a:avLst/>
+          </a:prstGeom>
+          <a:noFill/>
+        </p:spPr>
+        <p:txBody>
+          <a:bodyPr wrap="square">
+            <a:spAutoFit/>
+          </a:bodyPr>
+          <a:lstStyle/>
+          <a:p>
+            <a:r>
+              <a:rPr sz="960" b="1">
+                <a:solidFill>
+                  <a:srgbClr val="000000"/>
+                </a:solidFill>
+                <a:latin typeface="Segoe UI"/>
+                <a:hlinkClick r:id="rId2"/>
+              </a:rPr>
+              <a:t>▶ BUKA KODE LENGKAP DI GITHUB (slide_16_penyelamat_kategori_wrap.dart)</a:t>
+            </a:r>
+          </a:p>
+          <a:p>
+            <a:pPr>
+              <a:defRPr sz="760">
+                <a:solidFill>
+                  <a:srgbClr val="3C3C3C"/>
+                </a:solidFill>
+                <a:latin typeface="Segoe UI"/>
+              </a:defRPr>
+            </a:pPr>
+            <a:r>
+              <a:t>💡 Buka di browser / salin source code: github.com/antonprafanto/mobile2026</a:t>
             </a:r>
           </a:p>
         </p:txBody>
@@ -8584,8 +9536,8 @@
         </p:nvSpPr>
         <p:spPr>
           <a:xfrm>
-            <a:off x="5669280" y="2176272"/>
-            <a:ext cx="5486400" cy="3977639"/>
+            <a:off x="5669280" y="2121408"/>
+            <a:ext cx="5486400" cy="3364992"/>
           </a:xfrm>
           <a:prstGeom prst="rect">
             <a:avLst/>
@@ -8599,7 +9551,7 @@
           <a:lstStyle/>
           <a:p>
             <a:pPr>
-              <a:defRPr sz="980">
+              <a:defRPr sz="919">
                 <a:solidFill>
                   <a:srgbClr val="F5F5F5"/>
                 </a:solidFill>
@@ -8689,6 +9641,142 @@
             <a:br/>
             <a:r>
               <a:t>}</a:t>
+            </a:r>
+          </a:p>
+        </p:txBody>
+      </p:sp>
+      <p:sp>
+        <p:nvSpPr>
+          <p:cNvPr id="15" name="Rectangle 14"/>
+          <p:cNvSpPr/>
+          <p:nvPr/>
+        </p:nvSpPr>
+        <p:spPr>
+          <a:xfrm>
+            <a:off x="5660136" y="5669280"/>
+            <a:ext cx="5608015" cy="548640"/>
+          </a:xfrm>
+          <a:prstGeom prst="rect">
+            <a:avLst/>
+          </a:prstGeom>
+          <a:solidFill>
+            <a:srgbClr val="000000"/>
+          </a:solidFill>
+          <a:ln>
+            <a:noFill/>
+          </a:ln>
+        </p:spPr>
+        <p:style>
+          <a:lnRef idx="1">
+            <a:schemeClr val="accent1"/>
+          </a:lnRef>
+          <a:fillRef idx="3">
+            <a:schemeClr val="accent1"/>
+          </a:fillRef>
+          <a:effectRef idx="2">
+            <a:schemeClr val="accent1"/>
+          </a:effectRef>
+          <a:fontRef idx="minor">
+            <a:schemeClr val="lt1"/>
+          </a:fontRef>
+        </p:style>
+        <p:txBody>
+          <a:bodyPr rtlCol="0" anchor="ctr"/>
+          <a:lstStyle/>
+          <a:p>
+            <a:pPr algn="ctr"/>
+          </a:p>
+        </p:txBody>
+      </p:sp>
+      <p:sp>
+        <p:nvSpPr>
+          <p:cNvPr id="16" name="Rectangle 15"/>
+          <p:cNvSpPr/>
+          <p:nvPr/>
+        </p:nvSpPr>
+        <p:spPr>
+          <a:xfrm>
+            <a:off x="5623560" y="5632704"/>
+            <a:ext cx="5608015" cy="548640"/>
+          </a:xfrm>
+          <a:prstGeom prst="rect">
+            <a:avLst/>
+          </a:prstGeom>
+          <a:solidFill>
+            <a:srgbClr val="FFE600"/>
+          </a:solidFill>
+          <a:ln w="25400">
+            <a:solidFill>
+              <a:srgbClr val="000000"/>
+            </a:solidFill>
+          </a:ln>
+        </p:spPr>
+        <p:style>
+          <a:lnRef idx="1">
+            <a:schemeClr val="accent1"/>
+          </a:lnRef>
+          <a:fillRef idx="3">
+            <a:schemeClr val="accent1"/>
+          </a:fillRef>
+          <a:effectRef idx="2">
+            <a:schemeClr val="accent1"/>
+          </a:effectRef>
+          <a:fontRef idx="minor">
+            <a:schemeClr val="lt1"/>
+          </a:fontRef>
+        </p:style>
+        <p:txBody>
+          <a:bodyPr rtlCol="0" anchor="ctr"/>
+          <a:lstStyle/>
+          <a:p>
+            <a:pPr algn="ctr"/>
+          </a:p>
+        </p:txBody>
+      </p:sp>
+      <p:sp>
+        <p:nvSpPr>
+          <p:cNvPr id="17" name="TextBox 16"/>
+          <p:cNvSpPr txBox="1"/>
+          <p:nvPr/>
+        </p:nvSpPr>
+        <p:spPr>
+          <a:xfrm>
+            <a:off x="5696712" y="5660136"/>
+            <a:ext cx="5461711" cy="493776"/>
+          </a:xfrm>
+          <a:prstGeom prst="rect">
+            <a:avLst/>
+          </a:prstGeom>
+          <a:noFill/>
+        </p:spPr>
+        <p:txBody>
+          <a:bodyPr wrap="square">
+            <a:spAutoFit/>
+          </a:bodyPr>
+          <a:lstStyle/>
+          <a:p>
+            <a:r>
+              <a:rPr sz="960" b="1">
+                <a:solidFill>
+                  <a:srgbClr val="000000"/>
+                </a:solidFill>
+                <a:latin typeface="Segoe UI"/>
+                <a:hlinkClick r:id="rId2"/>
+              </a:rPr>
+              <a:t>▶ BUKA KODE LENGKAP DI GITHUB (slide_17_scrollable_singlechildscrollview.dart)</a:t>
+            </a:r>
+          </a:p>
+          <a:p>
+            <a:pPr>
+              <a:defRPr sz="760">
+                <a:solidFill>
+                  <a:srgbClr val="3C3C3C"/>
+                </a:solidFill>
+                <a:latin typeface="Segoe UI"/>
+              </a:defRPr>
+            </a:pPr>
+            <a:r>
+              <a:t>💡 Buka di browser / salin source code: github.com/antonprafanto/mobile2026</a:t>
             </a:r>
           </a:p>
         </p:txBody>
@@ -9279,8 +10367,8 @@
         </p:nvSpPr>
         <p:spPr>
           <a:xfrm>
-            <a:off x="5669280" y="2176272"/>
-            <a:ext cx="5486400" cy="3977639"/>
+            <a:off x="5669280" y="2121408"/>
+            <a:ext cx="5486400" cy="3364992"/>
           </a:xfrm>
           <a:prstGeom prst="rect">
             <a:avLst/>
@@ -9294,7 +10382,7 @@
           <a:lstStyle/>
           <a:p>
             <a:pPr>
-              <a:defRPr sz="980">
+              <a:defRPr sz="919">
                 <a:solidFill>
                   <a:srgbClr val="F5F5F5"/>
                 </a:solidFill>
@@ -9347,6 +10435,142 @@
             <a:br/>
             <a:r>
               <a:t>)</a:t>
+            </a:r>
+          </a:p>
+        </p:txBody>
+      </p:sp>
+      <p:sp>
+        <p:nvSpPr>
+          <p:cNvPr id="15" name="Rectangle 14"/>
+          <p:cNvSpPr/>
+          <p:nvPr/>
+        </p:nvSpPr>
+        <p:spPr>
+          <a:xfrm>
+            <a:off x="5660136" y="5669280"/>
+            <a:ext cx="5608015" cy="548640"/>
+          </a:xfrm>
+          <a:prstGeom prst="rect">
+            <a:avLst/>
+          </a:prstGeom>
+          <a:solidFill>
+            <a:srgbClr val="000000"/>
+          </a:solidFill>
+          <a:ln>
+            <a:noFill/>
+          </a:ln>
+        </p:spPr>
+        <p:style>
+          <a:lnRef idx="1">
+            <a:schemeClr val="accent1"/>
+          </a:lnRef>
+          <a:fillRef idx="3">
+            <a:schemeClr val="accent1"/>
+          </a:fillRef>
+          <a:effectRef idx="2">
+            <a:schemeClr val="accent1"/>
+          </a:effectRef>
+          <a:fontRef idx="minor">
+            <a:schemeClr val="lt1"/>
+          </a:fontRef>
+        </p:style>
+        <p:txBody>
+          <a:bodyPr rtlCol="0" anchor="ctr"/>
+          <a:lstStyle/>
+          <a:p>
+            <a:pPr algn="ctr"/>
+          </a:p>
+        </p:txBody>
+      </p:sp>
+      <p:sp>
+        <p:nvSpPr>
+          <p:cNvPr id="16" name="Rectangle 15"/>
+          <p:cNvSpPr/>
+          <p:nvPr/>
+        </p:nvSpPr>
+        <p:spPr>
+          <a:xfrm>
+            <a:off x="5623560" y="5632704"/>
+            <a:ext cx="5608015" cy="548640"/>
+          </a:xfrm>
+          <a:prstGeom prst="rect">
+            <a:avLst/>
+          </a:prstGeom>
+          <a:solidFill>
+            <a:srgbClr val="FFE600"/>
+          </a:solidFill>
+          <a:ln w="25400">
+            <a:solidFill>
+              <a:srgbClr val="000000"/>
+            </a:solidFill>
+          </a:ln>
+        </p:spPr>
+        <p:style>
+          <a:lnRef idx="1">
+            <a:schemeClr val="accent1"/>
+          </a:lnRef>
+          <a:fillRef idx="3">
+            <a:schemeClr val="accent1"/>
+          </a:fillRef>
+          <a:effectRef idx="2">
+            <a:schemeClr val="accent1"/>
+          </a:effectRef>
+          <a:fontRef idx="minor">
+            <a:schemeClr val="lt1"/>
+          </a:fontRef>
+        </p:style>
+        <p:txBody>
+          <a:bodyPr rtlCol="0" anchor="ctr"/>
+          <a:lstStyle/>
+          <a:p>
+            <a:pPr algn="ctr"/>
+          </a:p>
+        </p:txBody>
+      </p:sp>
+      <p:sp>
+        <p:nvSpPr>
+          <p:cNvPr id="17" name="TextBox 16"/>
+          <p:cNvSpPr txBox="1"/>
+          <p:nvPr/>
+        </p:nvSpPr>
+        <p:spPr>
+          <a:xfrm>
+            <a:off x="5696712" y="5660136"/>
+            <a:ext cx="5461711" cy="493776"/>
+          </a:xfrm>
+          <a:prstGeom prst="rect">
+            <a:avLst/>
+          </a:prstGeom>
+          <a:noFill/>
+        </p:spPr>
+        <p:txBody>
+          <a:bodyPr wrap="square">
+            <a:spAutoFit/>
+          </a:bodyPr>
+          <a:lstStyle/>
+          <a:p>
+            <a:r>
+              <a:rPr sz="960" b="1">
+                <a:solidFill>
+                  <a:srgbClr val="000000"/>
+                </a:solidFill>
+                <a:latin typeface="Segoe UI"/>
+                <a:hlinkClick r:id="rId2"/>
+              </a:rPr>
+              <a:t>▶ BUKA KODE LENGKAP DI GITHUB (slide_18_scrollable_listview_builder.dart)</a:t>
+            </a:r>
+          </a:p>
+          <a:p>
+            <a:pPr>
+              <a:defRPr sz="760">
+                <a:solidFill>
+                  <a:srgbClr val="3C3C3C"/>
+                </a:solidFill>
+                <a:latin typeface="Segoe UI"/>
+              </a:defRPr>
+            </a:pPr>
+            <a:r>
+              <a:t>💡 Buka di browser / salin source code: github.com/antonprafanto/mobile2026</a:t>
             </a:r>
           </a:p>
         </p:txBody>
@@ -9969,8 +11193,8 @@
         </p:nvSpPr>
         <p:spPr>
           <a:xfrm>
-            <a:off x="5669280" y="2176272"/>
-            <a:ext cx="5486400" cy="3977639"/>
+            <a:off x="5669280" y="2121408"/>
+            <a:ext cx="5486400" cy="3364992"/>
           </a:xfrm>
           <a:prstGeom prst="rect">
             <a:avLst/>
@@ -9984,7 +11208,7 @@
           <a:lstStyle/>
           <a:p>
             <a:pPr>
-              <a:defRPr sz="980">
+              <a:defRPr sz="919">
                 <a:solidFill>
                   <a:srgbClr val="F5F5F5"/>
                 </a:solidFill>
@@ -10049,6 +11273,142 @@
             <a:br/>
             <a:r>
               <a:t>)</a:t>
+            </a:r>
+          </a:p>
+        </p:txBody>
+      </p:sp>
+      <p:sp>
+        <p:nvSpPr>
+          <p:cNvPr id="15" name="Rectangle 14"/>
+          <p:cNvSpPr/>
+          <p:nvPr/>
+        </p:nvSpPr>
+        <p:spPr>
+          <a:xfrm>
+            <a:off x="5660136" y="5669280"/>
+            <a:ext cx="5608015" cy="548640"/>
+          </a:xfrm>
+          <a:prstGeom prst="rect">
+            <a:avLst/>
+          </a:prstGeom>
+          <a:solidFill>
+            <a:srgbClr val="000000"/>
+          </a:solidFill>
+          <a:ln>
+            <a:noFill/>
+          </a:ln>
+        </p:spPr>
+        <p:style>
+          <a:lnRef idx="1">
+            <a:schemeClr val="accent1"/>
+          </a:lnRef>
+          <a:fillRef idx="3">
+            <a:schemeClr val="accent1"/>
+          </a:fillRef>
+          <a:effectRef idx="2">
+            <a:schemeClr val="accent1"/>
+          </a:effectRef>
+          <a:fontRef idx="minor">
+            <a:schemeClr val="lt1"/>
+          </a:fontRef>
+        </p:style>
+        <p:txBody>
+          <a:bodyPr rtlCol="0" anchor="ctr"/>
+          <a:lstStyle/>
+          <a:p>
+            <a:pPr algn="ctr"/>
+          </a:p>
+        </p:txBody>
+      </p:sp>
+      <p:sp>
+        <p:nvSpPr>
+          <p:cNvPr id="16" name="Rectangle 15"/>
+          <p:cNvSpPr/>
+          <p:nvPr/>
+        </p:nvSpPr>
+        <p:spPr>
+          <a:xfrm>
+            <a:off x="5623560" y="5632704"/>
+            <a:ext cx="5608015" cy="548640"/>
+          </a:xfrm>
+          <a:prstGeom prst="rect">
+            <a:avLst/>
+          </a:prstGeom>
+          <a:solidFill>
+            <a:srgbClr val="FFE600"/>
+          </a:solidFill>
+          <a:ln w="25400">
+            <a:solidFill>
+              <a:srgbClr val="000000"/>
+            </a:solidFill>
+          </a:ln>
+        </p:spPr>
+        <p:style>
+          <a:lnRef idx="1">
+            <a:schemeClr val="accent1"/>
+          </a:lnRef>
+          <a:fillRef idx="3">
+            <a:schemeClr val="accent1"/>
+          </a:fillRef>
+          <a:effectRef idx="2">
+            <a:schemeClr val="accent1"/>
+          </a:effectRef>
+          <a:fontRef idx="minor">
+            <a:schemeClr val="lt1"/>
+          </a:fontRef>
+        </p:style>
+        <p:txBody>
+          <a:bodyPr rtlCol="0" anchor="ctr"/>
+          <a:lstStyle/>
+          <a:p>
+            <a:pPr algn="ctr"/>
+          </a:p>
+        </p:txBody>
+      </p:sp>
+      <p:sp>
+        <p:nvSpPr>
+          <p:cNvPr id="17" name="TextBox 16"/>
+          <p:cNvSpPr txBox="1"/>
+          <p:nvPr/>
+        </p:nvSpPr>
+        <p:spPr>
+          <a:xfrm>
+            <a:off x="5696712" y="5660136"/>
+            <a:ext cx="5461711" cy="493776"/>
+          </a:xfrm>
+          <a:prstGeom prst="rect">
+            <a:avLst/>
+          </a:prstGeom>
+          <a:noFill/>
+        </p:spPr>
+        <p:txBody>
+          <a:bodyPr wrap="square">
+            <a:spAutoFit/>
+          </a:bodyPr>
+          <a:lstStyle/>
+          <a:p>
+            <a:r>
+              <a:rPr sz="960" b="1">
+                <a:solidFill>
+                  <a:srgbClr val="000000"/>
+                </a:solidFill>
+                <a:latin typeface="Segoe UI"/>
+                <a:hlinkClick r:id="rId2"/>
+              </a:rPr>
+              <a:t>▶ BUKA KODE LENGKAP DI GITHUB (slide_19_scrollable_gridview_builder.dart)</a:t>
+            </a:r>
+          </a:p>
+          <a:p>
+            <a:pPr>
+              <a:defRPr sz="760">
+                <a:solidFill>
+                  <a:srgbClr val="3C3C3C"/>
+                </a:solidFill>
+                <a:latin typeface="Segoe UI"/>
+              </a:defRPr>
+            </a:pPr>
+            <a:r>
+              <a:t>💡 Buka di browser / salin source code: github.com/antonprafanto/mobile2026</a:t>
             </a:r>
           </a:p>
         </p:txBody>
@@ -10639,8 +11999,8 @@
         </p:nvSpPr>
         <p:spPr>
           <a:xfrm>
-            <a:off x="5669280" y="2176272"/>
-            <a:ext cx="5486400" cy="3977639"/>
+            <a:off x="5669280" y="2121408"/>
+            <a:ext cx="5486400" cy="3364992"/>
           </a:xfrm>
           <a:prstGeom prst="rect">
             <a:avLst/>
@@ -10654,7 +12014,7 @@
           <a:lstStyle/>
           <a:p>
             <a:pPr>
-              <a:defRPr sz="980">
+              <a:defRPr sz="919">
                 <a:solidFill>
                   <a:srgbClr val="F5F5F5"/>
                 </a:solidFill>
@@ -10698,6 +12058,142 @@
             <a:br/>
             <a:r>
               <a:t># tekan huruf 'r' pada terminal untuk Hot Reload!</a:t>
+            </a:r>
+          </a:p>
+        </p:txBody>
+      </p:sp>
+      <p:sp>
+        <p:nvSpPr>
+          <p:cNvPr id="15" name="Rectangle 14"/>
+          <p:cNvSpPr/>
+          <p:nvPr/>
+        </p:nvSpPr>
+        <p:spPr>
+          <a:xfrm>
+            <a:off x="5660136" y="5669280"/>
+            <a:ext cx="5608015" cy="548640"/>
+          </a:xfrm>
+          <a:prstGeom prst="rect">
+            <a:avLst/>
+          </a:prstGeom>
+          <a:solidFill>
+            <a:srgbClr val="000000"/>
+          </a:solidFill>
+          <a:ln>
+            <a:noFill/>
+          </a:ln>
+        </p:spPr>
+        <p:style>
+          <a:lnRef idx="1">
+            <a:schemeClr val="accent1"/>
+          </a:lnRef>
+          <a:fillRef idx="3">
+            <a:schemeClr val="accent1"/>
+          </a:fillRef>
+          <a:effectRef idx="2">
+            <a:schemeClr val="accent1"/>
+          </a:effectRef>
+          <a:fontRef idx="minor">
+            <a:schemeClr val="lt1"/>
+          </a:fontRef>
+        </p:style>
+        <p:txBody>
+          <a:bodyPr rtlCol="0" anchor="ctr"/>
+          <a:lstStyle/>
+          <a:p>
+            <a:pPr algn="ctr"/>
+          </a:p>
+        </p:txBody>
+      </p:sp>
+      <p:sp>
+        <p:nvSpPr>
+          <p:cNvPr id="16" name="Rectangle 15"/>
+          <p:cNvSpPr/>
+          <p:nvPr/>
+        </p:nvSpPr>
+        <p:spPr>
+          <a:xfrm>
+            <a:off x="5623560" y="5632704"/>
+            <a:ext cx="5608015" cy="548640"/>
+          </a:xfrm>
+          <a:prstGeom prst="rect">
+            <a:avLst/>
+          </a:prstGeom>
+          <a:solidFill>
+            <a:srgbClr val="FFE600"/>
+          </a:solidFill>
+          <a:ln w="25400">
+            <a:solidFill>
+              <a:srgbClr val="000000"/>
+            </a:solidFill>
+          </a:ln>
+        </p:spPr>
+        <p:style>
+          <a:lnRef idx="1">
+            <a:schemeClr val="accent1"/>
+          </a:lnRef>
+          <a:fillRef idx="3">
+            <a:schemeClr val="accent1"/>
+          </a:fillRef>
+          <a:effectRef idx="2">
+            <a:schemeClr val="accent1"/>
+          </a:effectRef>
+          <a:fontRef idx="minor">
+            <a:schemeClr val="lt1"/>
+          </a:fontRef>
+        </p:style>
+        <p:txBody>
+          <a:bodyPr rtlCol="0" anchor="ctr"/>
+          <a:lstStyle/>
+          <a:p>
+            <a:pPr algn="ctr"/>
+          </a:p>
+        </p:txBody>
+      </p:sp>
+      <p:sp>
+        <p:nvSpPr>
+          <p:cNvPr id="17" name="TextBox 16"/>
+          <p:cNvSpPr txBox="1"/>
+          <p:nvPr/>
+        </p:nvSpPr>
+        <p:spPr>
+          <a:xfrm>
+            <a:off x="5696712" y="5660136"/>
+            <a:ext cx="5461711" cy="493776"/>
+          </a:xfrm>
+          <a:prstGeom prst="rect">
+            <a:avLst/>
+          </a:prstGeom>
+          <a:noFill/>
+        </p:spPr>
+        <p:txBody>
+          <a:bodyPr wrap="square">
+            <a:spAutoFit/>
+          </a:bodyPr>
+          <a:lstStyle/>
+          <a:p>
+            <a:r>
+              <a:rPr sz="960" b="1">
+                <a:solidFill>
+                  <a:srgbClr val="000000"/>
+                </a:solidFill>
+                <a:latin typeface="Segoe UI"/>
+                <a:hlinkClick r:id="rId2"/>
+              </a:rPr>
+              <a:t>▶ BUKA KODE LENGKAP DI GITHUB (slide_02_panduan_tools_dan_workflow.dart)</a:t>
+            </a:r>
+          </a:p>
+          <a:p>
+            <a:pPr>
+              <a:defRPr sz="760">
+                <a:solidFill>
+                  <a:srgbClr val="3C3C3C"/>
+                </a:solidFill>
+                <a:latin typeface="Segoe UI"/>
+              </a:defRPr>
+            </a:pPr>
+            <a:r>
+              <a:t>💡 Buka di browser / salin source code: github.com/antonprafanto/mobile2026</a:t>
             </a:r>
           </a:p>
         </p:txBody>
@@ -11288,8 +12784,8 @@
         </p:nvSpPr>
         <p:spPr>
           <a:xfrm>
-            <a:off x="5669280" y="2176272"/>
-            <a:ext cx="5486400" cy="3977639"/>
+            <a:off x="5669280" y="2121408"/>
+            <a:ext cx="5486400" cy="3364992"/>
           </a:xfrm>
           <a:prstGeom prst="rect">
             <a:avLst/>
@@ -11303,7 +12799,7 @@
           <a:lstStyle/>
           <a:p>
             <a:pPr>
-              <a:defRPr sz="980">
+              <a:defRPr sz="919">
                 <a:solidFill>
                   <a:srgbClr val="F5F5F5"/>
                 </a:solidFill>
@@ -11364,6 +12860,142 @@
             <a:br/>
             <a:r>
               <a:t>)</a:t>
+            </a:r>
+          </a:p>
+        </p:txBody>
+      </p:sp>
+      <p:sp>
+        <p:nvSpPr>
+          <p:cNvPr id="15" name="Rectangle 14"/>
+          <p:cNvSpPr/>
+          <p:nvPr/>
+        </p:nvSpPr>
+        <p:spPr>
+          <a:xfrm>
+            <a:off x="5660136" y="5669280"/>
+            <a:ext cx="5608015" cy="548640"/>
+          </a:xfrm>
+          <a:prstGeom prst="rect">
+            <a:avLst/>
+          </a:prstGeom>
+          <a:solidFill>
+            <a:srgbClr val="000000"/>
+          </a:solidFill>
+          <a:ln>
+            <a:noFill/>
+          </a:ln>
+        </p:spPr>
+        <p:style>
+          <a:lnRef idx="1">
+            <a:schemeClr val="accent1"/>
+          </a:lnRef>
+          <a:fillRef idx="3">
+            <a:schemeClr val="accent1"/>
+          </a:fillRef>
+          <a:effectRef idx="2">
+            <a:schemeClr val="accent1"/>
+          </a:effectRef>
+          <a:fontRef idx="minor">
+            <a:schemeClr val="lt1"/>
+          </a:fontRef>
+        </p:style>
+        <p:txBody>
+          <a:bodyPr rtlCol="0" anchor="ctr"/>
+          <a:lstStyle/>
+          <a:p>
+            <a:pPr algn="ctr"/>
+          </a:p>
+        </p:txBody>
+      </p:sp>
+      <p:sp>
+        <p:nvSpPr>
+          <p:cNvPr id="16" name="Rectangle 15"/>
+          <p:cNvSpPr/>
+          <p:nvPr/>
+        </p:nvSpPr>
+        <p:spPr>
+          <a:xfrm>
+            <a:off x="5623560" y="5632704"/>
+            <a:ext cx="5608015" cy="548640"/>
+          </a:xfrm>
+          <a:prstGeom prst="rect">
+            <a:avLst/>
+          </a:prstGeom>
+          <a:solidFill>
+            <a:srgbClr val="FFE600"/>
+          </a:solidFill>
+          <a:ln w="25400">
+            <a:solidFill>
+              <a:srgbClr val="000000"/>
+            </a:solidFill>
+          </a:ln>
+        </p:spPr>
+        <p:style>
+          <a:lnRef idx="1">
+            <a:schemeClr val="accent1"/>
+          </a:lnRef>
+          <a:fillRef idx="3">
+            <a:schemeClr val="accent1"/>
+          </a:fillRef>
+          <a:effectRef idx="2">
+            <a:schemeClr val="accent1"/>
+          </a:effectRef>
+          <a:fontRef idx="minor">
+            <a:schemeClr val="lt1"/>
+          </a:fontRef>
+        </p:style>
+        <p:txBody>
+          <a:bodyPr rtlCol="0" anchor="ctr"/>
+          <a:lstStyle/>
+          <a:p>
+            <a:pPr algn="ctr"/>
+          </a:p>
+        </p:txBody>
+      </p:sp>
+      <p:sp>
+        <p:nvSpPr>
+          <p:cNvPr id="17" name="TextBox 16"/>
+          <p:cNvSpPr txBox="1"/>
+          <p:nvPr/>
+        </p:nvSpPr>
+        <p:spPr>
+          <a:xfrm>
+            <a:off x="5696712" y="5660136"/>
+            <a:ext cx="5461711" cy="493776"/>
+          </a:xfrm>
+          <a:prstGeom prst="rect">
+            <a:avLst/>
+          </a:prstGeom>
+          <a:noFill/>
+        </p:spPr>
+        <p:txBody>
+          <a:bodyPr wrap="square">
+            <a:spAutoFit/>
+          </a:bodyPr>
+          <a:lstStyle/>
+          <a:p>
+            <a:r>
+              <a:rPr sz="960" b="1">
+                <a:solidFill>
+                  <a:srgbClr val="000000"/>
+                </a:solidFill>
+                <a:latin typeface="Segoe UI"/>
+                <a:hlinkClick r:id="rId2"/>
+              </a:rPr>
+              <a:t>▶ BUKA KODE LENGKAP DI GITHUB (slide_20_solusi_renderflex_overflow.dart)</a:t>
+            </a:r>
+          </a:p>
+          <a:p>
+            <a:pPr>
+              <a:defRPr sz="760">
+                <a:solidFill>
+                  <a:srgbClr val="3C3C3C"/>
+                </a:solidFill>
+                <a:latin typeface="Segoe UI"/>
+              </a:defRPr>
+            </a:pPr>
+            <a:r>
+              <a:t>💡 Buka di browser / salin source code: github.com/antonprafanto/mobile2026</a:t>
             </a:r>
           </a:p>
         </p:txBody>
@@ -11970,8 +13602,8 @@
         </p:nvSpPr>
         <p:spPr>
           <a:xfrm>
-            <a:off x="5669280" y="2176272"/>
-            <a:ext cx="5486400" cy="3977639"/>
+            <a:off x="5669280" y="2121408"/>
+            <a:ext cx="5486400" cy="3364992"/>
           </a:xfrm>
           <a:prstGeom prst="rect">
             <a:avLst/>
@@ -11985,7 +13617,7 @@
           <a:lstStyle/>
           <a:p>
             <a:pPr>
-              <a:defRPr sz="980">
+              <a:defRPr sz="919">
                 <a:solidFill>
                   <a:srgbClr val="F5F5F5"/>
                 </a:solidFill>
@@ -12046,6 +13678,142 @@
             <a:br/>
             <a:r>
               <a:t>)</a:t>
+            </a:r>
+          </a:p>
+        </p:txBody>
+      </p:sp>
+      <p:sp>
+        <p:nvSpPr>
+          <p:cNvPr id="15" name="Rectangle 14"/>
+          <p:cNvSpPr/>
+          <p:nvPr/>
+        </p:nvSpPr>
+        <p:spPr>
+          <a:xfrm>
+            <a:off x="5660136" y="5669280"/>
+            <a:ext cx="5608015" cy="548640"/>
+          </a:xfrm>
+          <a:prstGeom prst="rect">
+            <a:avLst/>
+          </a:prstGeom>
+          <a:solidFill>
+            <a:srgbClr val="000000"/>
+          </a:solidFill>
+          <a:ln>
+            <a:noFill/>
+          </a:ln>
+        </p:spPr>
+        <p:style>
+          <a:lnRef idx="1">
+            <a:schemeClr val="accent1"/>
+          </a:lnRef>
+          <a:fillRef idx="3">
+            <a:schemeClr val="accent1"/>
+          </a:fillRef>
+          <a:effectRef idx="2">
+            <a:schemeClr val="accent1"/>
+          </a:effectRef>
+          <a:fontRef idx="minor">
+            <a:schemeClr val="lt1"/>
+          </a:fontRef>
+        </p:style>
+        <p:txBody>
+          <a:bodyPr rtlCol="0" anchor="ctr"/>
+          <a:lstStyle/>
+          <a:p>
+            <a:pPr algn="ctr"/>
+          </a:p>
+        </p:txBody>
+      </p:sp>
+      <p:sp>
+        <p:nvSpPr>
+          <p:cNvPr id="16" name="Rectangle 15"/>
+          <p:cNvSpPr/>
+          <p:nvPr/>
+        </p:nvSpPr>
+        <p:spPr>
+          <a:xfrm>
+            <a:off x="5623560" y="5632704"/>
+            <a:ext cx="5608015" cy="548640"/>
+          </a:xfrm>
+          <a:prstGeom prst="rect">
+            <a:avLst/>
+          </a:prstGeom>
+          <a:solidFill>
+            <a:srgbClr val="FFE600"/>
+          </a:solidFill>
+          <a:ln w="25400">
+            <a:solidFill>
+              <a:srgbClr val="000000"/>
+            </a:solidFill>
+          </a:ln>
+        </p:spPr>
+        <p:style>
+          <a:lnRef idx="1">
+            <a:schemeClr val="accent1"/>
+          </a:lnRef>
+          <a:fillRef idx="3">
+            <a:schemeClr val="accent1"/>
+          </a:fillRef>
+          <a:effectRef idx="2">
+            <a:schemeClr val="accent1"/>
+          </a:effectRef>
+          <a:fontRef idx="minor">
+            <a:schemeClr val="lt1"/>
+          </a:fontRef>
+        </p:style>
+        <p:txBody>
+          <a:bodyPr rtlCol="0" anchor="ctr"/>
+          <a:lstStyle/>
+          <a:p>
+            <a:pPr algn="ctr"/>
+          </a:p>
+        </p:txBody>
+      </p:sp>
+      <p:sp>
+        <p:nvSpPr>
+          <p:cNvPr id="17" name="TextBox 16"/>
+          <p:cNvSpPr txBox="1"/>
+          <p:nvPr/>
+        </p:nvSpPr>
+        <p:spPr>
+          <a:xfrm>
+            <a:off x="5696712" y="5660136"/>
+            <a:ext cx="5461711" cy="493776"/>
+          </a:xfrm>
+          <a:prstGeom prst="rect">
+            <a:avLst/>
+          </a:prstGeom>
+          <a:noFill/>
+        </p:spPr>
+        <p:txBody>
+          <a:bodyPr wrap="square">
+            <a:spAutoFit/>
+          </a:bodyPr>
+          <a:lstStyle/>
+          <a:p>
+            <a:r>
+              <a:rPr sz="960" b="1">
+                <a:solidFill>
+                  <a:srgbClr val="000000"/>
+                </a:solidFill>
+                <a:latin typeface="Segoe UI"/>
+                <a:hlinkClick r:id="rId2"/>
+              </a:rPr>
+              <a:t>▶ BUKA KODE LENGKAP DI GITHUB (slide_21_solusi_unbounded_height.dart)</a:t>
+            </a:r>
+          </a:p>
+          <a:p>
+            <a:pPr>
+              <a:defRPr sz="760">
+                <a:solidFill>
+                  <a:srgbClr val="3C3C3C"/>
+                </a:solidFill>
+                <a:latin typeface="Segoe UI"/>
+              </a:defRPr>
+            </a:pPr>
+            <a:r>
+              <a:t>💡 Buka di browser / salin source code: github.com/antonprafanto/mobile2026</a:t>
             </a:r>
           </a:p>
         </p:txBody>
@@ -12652,8 +14420,8 @@
         </p:nvSpPr>
         <p:spPr>
           <a:xfrm>
-            <a:off x="5669280" y="2176272"/>
-            <a:ext cx="5486400" cy="3977639"/>
+            <a:off x="5669280" y="2121408"/>
+            <a:ext cx="5486400" cy="3364992"/>
           </a:xfrm>
           <a:prstGeom prst="rect">
             <a:avLst/>
@@ -12667,7 +14435,7 @@
           <a:lstStyle/>
           <a:p>
             <a:pPr>
-              <a:defRPr sz="980">
+              <a:defRPr sz="919">
                 <a:solidFill>
                   <a:srgbClr val="F5F5F5"/>
                 </a:solidFill>
@@ -12721,6 +14489,142 @@
             <a:br/>
             <a:r>
               <a:t>) // &lt;- Ada koma</a:t>
+            </a:r>
+          </a:p>
+        </p:txBody>
+      </p:sp>
+      <p:sp>
+        <p:nvSpPr>
+          <p:cNvPr id="15" name="Rectangle 14"/>
+          <p:cNvSpPr/>
+          <p:nvPr/>
+        </p:nvSpPr>
+        <p:spPr>
+          <a:xfrm>
+            <a:off x="5660136" y="5669280"/>
+            <a:ext cx="5608015" cy="548640"/>
+          </a:xfrm>
+          <a:prstGeom prst="rect">
+            <a:avLst/>
+          </a:prstGeom>
+          <a:solidFill>
+            <a:srgbClr val="000000"/>
+          </a:solidFill>
+          <a:ln>
+            <a:noFill/>
+          </a:ln>
+        </p:spPr>
+        <p:style>
+          <a:lnRef idx="1">
+            <a:schemeClr val="accent1"/>
+          </a:lnRef>
+          <a:fillRef idx="3">
+            <a:schemeClr val="accent1"/>
+          </a:fillRef>
+          <a:effectRef idx="2">
+            <a:schemeClr val="accent1"/>
+          </a:effectRef>
+          <a:fontRef idx="minor">
+            <a:schemeClr val="lt1"/>
+          </a:fontRef>
+        </p:style>
+        <p:txBody>
+          <a:bodyPr rtlCol="0" anchor="ctr"/>
+          <a:lstStyle/>
+          <a:p>
+            <a:pPr algn="ctr"/>
+          </a:p>
+        </p:txBody>
+      </p:sp>
+      <p:sp>
+        <p:nvSpPr>
+          <p:cNvPr id="16" name="Rectangle 15"/>
+          <p:cNvSpPr/>
+          <p:nvPr/>
+        </p:nvSpPr>
+        <p:spPr>
+          <a:xfrm>
+            <a:off x="5623560" y="5632704"/>
+            <a:ext cx="5608015" cy="548640"/>
+          </a:xfrm>
+          <a:prstGeom prst="rect">
+            <a:avLst/>
+          </a:prstGeom>
+          <a:solidFill>
+            <a:srgbClr val="FFE600"/>
+          </a:solidFill>
+          <a:ln w="25400">
+            <a:solidFill>
+              <a:srgbClr val="000000"/>
+            </a:solidFill>
+          </a:ln>
+        </p:spPr>
+        <p:style>
+          <a:lnRef idx="1">
+            <a:schemeClr val="accent1"/>
+          </a:lnRef>
+          <a:fillRef idx="3">
+            <a:schemeClr val="accent1"/>
+          </a:fillRef>
+          <a:effectRef idx="2">
+            <a:schemeClr val="accent1"/>
+          </a:effectRef>
+          <a:fontRef idx="minor">
+            <a:schemeClr val="lt1"/>
+          </a:fontRef>
+        </p:style>
+        <p:txBody>
+          <a:bodyPr rtlCol="0" anchor="ctr"/>
+          <a:lstStyle/>
+          <a:p>
+            <a:pPr algn="ctr"/>
+          </a:p>
+        </p:txBody>
+      </p:sp>
+      <p:sp>
+        <p:nvSpPr>
+          <p:cNvPr id="17" name="TextBox 16"/>
+          <p:cNvSpPr txBox="1"/>
+          <p:nvPr/>
+        </p:nvSpPr>
+        <p:spPr>
+          <a:xfrm>
+            <a:off x="5696712" y="5660136"/>
+            <a:ext cx="5461711" cy="493776"/>
+          </a:xfrm>
+          <a:prstGeom prst="rect">
+            <a:avLst/>
+          </a:prstGeom>
+          <a:noFill/>
+        </p:spPr>
+        <p:txBody>
+          <a:bodyPr wrap="square">
+            <a:spAutoFit/>
+          </a:bodyPr>
+          <a:lstStyle/>
+          <a:p>
+            <a:r>
+              <a:rPr sz="960" b="1">
+                <a:solidFill>
+                  <a:srgbClr val="000000"/>
+                </a:solidFill>
+                <a:latin typeface="Segoe UI"/>
+                <a:hlinkClick r:id="rId2"/>
+              </a:rPr>
+              <a:t>▶ BUKA KODE LENGKAP DI GITHUB (slide_22_trik_koma_ajaib_trailing.dart)</a:t>
+            </a:r>
+          </a:p>
+          <a:p>
+            <a:pPr>
+              <a:defRPr sz="760">
+                <a:solidFill>
+                  <a:srgbClr val="3C3C3C"/>
+                </a:solidFill>
+                <a:latin typeface="Segoe UI"/>
+              </a:defRPr>
+            </a:pPr>
+            <a:r>
+              <a:t>💡 Buka di browser / salin source code: github.com/antonprafanto/mobile2026</a:t>
             </a:r>
           </a:p>
         </p:txBody>
@@ -13327,8 +15231,8 @@
         </p:nvSpPr>
         <p:spPr>
           <a:xfrm>
-            <a:off x="5669280" y="2176272"/>
-            <a:ext cx="5486400" cy="3977639"/>
+            <a:off x="5669280" y="2121408"/>
+            <a:ext cx="5486400" cy="3364992"/>
           </a:xfrm>
           <a:prstGeom prst="rect">
             <a:avLst/>
@@ -13342,7 +15246,7 @@
           <a:lstStyle/>
           <a:p>
             <a:pPr>
-              <a:defRPr sz="980">
+              <a:defRPr sz="919">
                 <a:solidFill>
                   <a:srgbClr val="F5F5F5"/>
                 </a:solidFill>
@@ -13393,6 +15297,142 @@
             <a:br/>
             <a:r>
               <a:t>)</a:t>
+            </a:r>
+          </a:p>
+        </p:txBody>
+      </p:sp>
+      <p:sp>
+        <p:nvSpPr>
+          <p:cNvPr id="15" name="Rectangle 14"/>
+          <p:cNvSpPr/>
+          <p:nvPr/>
+        </p:nvSpPr>
+        <p:spPr>
+          <a:xfrm>
+            <a:off x="5660136" y="5669280"/>
+            <a:ext cx="5608015" cy="548640"/>
+          </a:xfrm>
+          <a:prstGeom prst="rect">
+            <a:avLst/>
+          </a:prstGeom>
+          <a:solidFill>
+            <a:srgbClr val="000000"/>
+          </a:solidFill>
+          <a:ln>
+            <a:noFill/>
+          </a:ln>
+        </p:spPr>
+        <p:style>
+          <a:lnRef idx="1">
+            <a:schemeClr val="accent1"/>
+          </a:lnRef>
+          <a:fillRef idx="3">
+            <a:schemeClr val="accent1"/>
+          </a:fillRef>
+          <a:effectRef idx="2">
+            <a:schemeClr val="accent1"/>
+          </a:effectRef>
+          <a:fontRef idx="minor">
+            <a:schemeClr val="lt1"/>
+          </a:fontRef>
+        </p:style>
+        <p:txBody>
+          <a:bodyPr rtlCol="0" anchor="ctr"/>
+          <a:lstStyle/>
+          <a:p>
+            <a:pPr algn="ctr"/>
+          </a:p>
+        </p:txBody>
+      </p:sp>
+      <p:sp>
+        <p:nvSpPr>
+          <p:cNvPr id="16" name="Rectangle 15"/>
+          <p:cNvSpPr/>
+          <p:nvPr/>
+        </p:nvSpPr>
+        <p:spPr>
+          <a:xfrm>
+            <a:off x="5623560" y="5632704"/>
+            <a:ext cx="5608015" cy="548640"/>
+          </a:xfrm>
+          <a:prstGeom prst="rect">
+            <a:avLst/>
+          </a:prstGeom>
+          <a:solidFill>
+            <a:srgbClr val="FFE600"/>
+          </a:solidFill>
+          <a:ln w="25400">
+            <a:solidFill>
+              <a:srgbClr val="000000"/>
+            </a:solidFill>
+          </a:ln>
+        </p:spPr>
+        <p:style>
+          <a:lnRef idx="1">
+            <a:schemeClr val="accent1"/>
+          </a:lnRef>
+          <a:fillRef idx="3">
+            <a:schemeClr val="accent1"/>
+          </a:fillRef>
+          <a:effectRef idx="2">
+            <a:schemeClr val="accent1"/>
+          </a:effectRef>
+          <a:fontRef idx="minor">
+            <a:schemeClr val="lt1"/>
+          </a:fontRef>
+        </p:style>
+        <p:txBody>
+          <a:bodyPr rtlCol="0" anchor="ctr"/>
+          <a:lstStyle/>
+          <a:p>
+            <a:pPr algn="ctr"/>
+          </a:p>
+        </p:txBody>
+      </p:sp>
+      <p:sp>
+        <p:nvSpPr>
+          <p:cNvPr id="17" name="TextBox 16"/>
+          <p:cNvSpPr txBox="1"/>
+          <p:nvPr/>
+        </p:nvSpPr>
+        <p:spPr>
+          <a:xfrm>
+            <a:off x="5696712" y="5660136"/>
+            <a:ext cx="5461711" cy="493776"/>
+          </a:xfrm>
+          <a:prstGeom prst="rect">
+            <a:avLst/>
+          </a:prstGeom>
+          <a:noFill/>
+        </p:spPr>
+        <p:txBody>
+          <a:bodyPr wrap="square">
+            <a:spAutoFit/>
+          </a:bodyPr>
+          <a:lstStyle/>
+          <a:p>
+            <a:r>
+              <a:rPr sz="960" b="1">
+                <a:solidFill>
+                  <a:srgbClr val="000000"/>
+                </a:solidFill>
+                <a:latin typeface="Segoe UI"/>
+                <a:hlinkClick r:id="rId2"/>
+              </a:rPr>
+              <a:t>▶ BUKA KODE LENGKAP DI GITHUB (slide_23_shortcut_refactor_inspector.dart)</a:t>
+            </a:r>
+          </a:p>
+          <a:p>
+            <a:pPr>
+              <a:defRPr sz="760">
+                <a:solidFill>
+                  <a:srgbClr val="3C3C3C"/>
+                </a:solidFill>
+                <a:latin typeface="Segoe UI"/>
+              </a:defRPr>
+            </a:pPr>
+            <a:r>
+              <a:t>💡 Buka di browser / salin source code: github.com/antonprafanto/mobile2026</a:t>
             </a:r>
           </a:p>
         </p:txBody>
@@ -13795,8 +15835,8 @@
         </p:nvSpPr>
         <p:spPr>
           <a:xfrm>
-            <a:off x="1188720" y="2240280"/>
-            <a:ext cx="9784080" cy="3931920"/>
+            <a:off x="1188720" y="2212848"/>
+            <a:ext cx="9784080" cy="3291840"/>
           </a:xfrm>
           <a:prstGeom prst="rect">
             <a:avLst/>
@@ -13811,9 +15851,9 @@
           <a:p>
             <a:pPr>
               <a:spcAft>
-                <a:spcPts val="500"/>
+                <a:spcPts val="400"/>
               </a:spcAft>
-              <a:defRPr sz="1450" b="1">
+              <a:defRPr sz="1350" b="1">
                 <a:solidFill>
                   <a:srgbClr val="000000"/>
                 </a:solidFill>
@@ -13827,9 +15867,9 @@
           <a:p>
             <a:pPr>
               <a:spcAft>
-                <a:spcPts val="300"/>
+                <a:spcPts val="200"/>
               </a:spcAft>
-              <a:defRPr sz="1100">
+              <a:defRPr sz="1050">
                 <a:solidFill>
                   <a:srgbClr val="1E1E1E"/>
                 </a:solidFill>
@@ -13843,9 +15883,9 @@
           <a:p>
             <a:pPr>
               <a:spcAft>
-                <a:spcPts val="300"/>
+                <a:spcPts val="200"/>
               </a:spcAft>
-              <a:defRPr sz="1100">
+              <a:defRPr sz="1050">
                 <a:solidFill>
                   <a:srgbClr val="1E1E1E"/>
                 </a:solidFill>
@@ -13859,9 +15899,9 @@
           <a:p>
             <a:pPr>
               <a:spcAft>
-                <a:spcPts val="300"/>
+                <a:spcPts val="200"/>
               </a:spcAft>
-              <a:defRPr sz="1100">
+              <a:defRPr sz="1050">
                 <a:solidFill>
                   <a:srgbClr val="1E1E1E"/>
                 </a:solidFill>
@@ -13875,9 +15915,9 @@
           <a:p>
             <a:pPr>
               <a:spcAft>
-                <a:spcPts val="300"/>
+                <a:spcPts val="200"/>
               </a:spcAft>
-              <a:defRPr sz="1100">
+              <a:defRPr sz="1050">
                 <a:solidFill>
                   <a:srgbClr val="1E1E1E"/>
                 </a:solidFill>
@@ -13891,9 +15931,9 @@
           <a:p>
             <a:pPr>
               <a:spcAft>
-                <a:spcPts val="300"/>
+                <a:spcPts val="200"/>
               </a:spcAft>
-              <a:defRPr sz="1100">
+              <a:defRPr sz="1050">
                 <a:solidFill>
                   <a:srgbClr val="1E1E1E"/>
                 </a:solidFill>
@@ -13907,9 +15947,9 @@
           <a:p>
             <a:pPr>
               <a:spcAft>
-                <a:spcPts val="300"/>
+                <a:spcPts val="200"/>
               </a:spcAft>
-              <a:defRPr sz="1100">
+              <a:defRPr sz="1050">
                 <a:solidFill>
                   <a:srgbClr val="1E1E1E"/>
                 </a:solidFill>
@@ -13923,9 +15963,9 @@
           <a:p>
             <a:pPr>
               <a:spcAft>
-                <a:spcPts val="300"/>
+                <a:spcPts val="200"/>
               </a:spcAft>
-              <a:defRPr sz="1100">
+              <a:defRPr sz="1050">
                 <a:solidFill>
                   <a:srgbClr val="1E1E1E"/>
                 </a:solidFill>
@@ -13939,9 +15979,9 @@
           <a:p>
             <a:pPr>
               <a:spcAft>
-                <a:spcPts val="300"/>
+                <a:spcPts val="200"/>
               </a:spcAft>
-              <a:defRPr sz="1100">
+              <a:defRPr sz="1050">
                 <a:solidFill>
                   <a:srgbClr val="1E1E1E"/>
                 </a:solidFill>
@@ -13953,9 +15993,8 @@
             </a:r>
           </a:p>
           <a:p>
-            <a:br/>
-            <a:pPr>
-              <a:defRPr sz="1150" b="1">
+            <a:pPr>
+              <a:defRPr sz="1100" b="1">
                 <a:solidFill>
                   <a:srgbClr val="00823C"/>
                 </a:solidFill>
@@ -13963,11 +16002,143 @@
               </a:defRPr>
             </a:pPr>
             <a:r>
-              <a:t>✔ Kriteria Keberhasilan (Tunjukkan ke Dosen/Asisten Lab):</a:t>
-            </a:r>
-            <a:br/>
-            <a:r>
-              <a:t>Tunjukkan kartu KTM Digital + Grid Menu di layar monitor/HP. Bebas 100% dari garis belang overflow dan rapi di bawah SafeArea!</a:t>
+              <a:t>✔ Kriteria Keberhasilan (Tunjukkan ke Dosen/Asisten Lab): Tunjukkan kartu KTM Digital + Grid Menu di layar monitor/HP. Bebas 100% dari garis belang overflow dan rapi di bawah SafeArea!</a:t>
+            </a:r>
+          </a:p>
+        </p:txBody>
+      </p:sp>
+      <p:sp>
+        <p:nvSpPr>
+          <p:cNvPr id="12" name="Rectangle 11"/>
+          <p:cNvSpPr/>
+          <p:nvPr/>
+        </p:nvSpPr>
+        <p:spPr>
+          <a:xfrm>
+            <a:off x="1225296" y="5669280"/>
+            <a:ext cx="9784080" cy="502920"/>
+          </a:xfrm>
+          <a:prstGeom prst="rect">
+            <a:avLst/>
+          </a:prstGeom>
+          <a:solidFill>
+            <a:srgbClr val="000000"/>
+          </a:solidFill>
+          <a:ln>
+            <a:noFill/>
+          </a:ln>
+        </p:spPr>
+        <p:style>
+          <a:lnRef idx="1">
+            <a:schemeClr val="accent1"/>
+          </a:lnRef>
+          <a:fillRef idx="3">
+            <a:schemeClr val="accent1"/>
+          </a:fillRef>
+          <a:effectRef idx="2">
+            <a:schemeClr val="accent1"/>
+          </a:effectRef>
+          <a:fontRef idx="minor">
+            <a:schemeClr val="lt1"/>
+          </a:fontRef>
+        </p:style>
+        <p:txBody>
+          <a:bodyPr rtlCol="0" anchor="ctr"/>
+          <a:lstStyle/>
+          <a:p>
+            <a:pPr algn="ctr"/>
+          </a:p>
+        </p:txBody>
+      </p:sp>
+      <p:sp>
+        <p:nvSpPr>
+          <p:cNvPr id="13" name="Rectangle 12"/>
+          <p:cNvSpPr/>
+          <p:nvPr/>
+        </p:nvSpPr>
+        <p:spPr>
+          <a:xfrm>
+            <a:off x="1188720" y="5632704"/>
+            <a:ext cx="9784080" cy="502920"/>
+          </a:xfrm>
+          <a:prstGeom prst="rect">
+            <a:avLst/>
+          </a:prstGeom>
+          <a:solidFill>
+            <a:srgbClr val="4ADE80"/>
+          </a:solidFill>
+          <a:ln w="25400">
+            <a:solidFill>
+              <a:srgbClr val="000000"/>
+            </a:solidFill>
+          </a:ln>
+        </p:spPr>
+        <p:style>
+          <a:lnRef idx="1">
+            <a:schemeClr val="accent1"/>
+          </a:lnRef>
+          <a:fillRef idx="3">
+            <a:schemeClr val="accent1"/>
+          </a:fillRef>
+          <a:effectRef idx="2">
+            <a:schemeClr val="accent1"/>
+          </a:effectRef>
+          <a:fontRef idx="minor">
+            <a:schemeClr val="lt1"/>
+          </a:fontRef>
+        </p:style>
+        <p:txBody>
+          <a:bodyPr rtlCol="0" anchor="ctr"/>
+          <a:lstStyle/>
+          <a:p>
+            <a:pPr algn="ctr"/>
+          </a:p>
+        </p:txBody>
+      </p:sp>
+      <p:sp>
+        <p:nvSpPr>
+          <p:cNvPr id="14" name="TextBox 13"/>
+          <p:cNvSpPr txBox="1"/>
+          <p:nvPr/>
+        </p:nvSpPr>
+        <p:spPr>
+          <a:xfrm>
+            <a:off x="1261872" y="5660136"/>
+            <a:ext cx="9637776" cy="448056"/>
+          </a:xfrm>
+          <a:prstGeom prst="rect">
+            <a:avLst/>
+          </a:prstGeom>
+          <a:noFill/>
+        </p:spPr>
+        <p:txBody>
+          <a:bodyPr wrap="square">
+            <a:spAutoFit/>
+          </a:bodyPr>
+          <a:lstStyle/>
+          <a:p>
+            <a:r>
+              <a:rPr sz="1000" b="1">
+                <a:solidFill>
+                  <a:srgbClr val="000000"/>
+                </a:solidFill>
+                <a:latin typeface="Segoe UI"/>
+                <a:hlinkClick r:id="rId2"/>
+              </a:rPr>
+              <a:t>▶ BUKA KODE SOLUSI LENGKAP LAB QUEST DI GITHUB (slide_24_lab_quest_dashboard_profil.dart)</a:t>
+            </a:r>
+          </a:p>
+          <a:p>
+            <a:pPr>
+              <a:defRPr sz="800">
+                <a:solidFill>
+                  <a:srgbClr val="3C3C3C"/>
+                </a:solidFill>
+                <a:latin typeface="Segoe UI"/>
+              </a:defRPr>
+            </a:pPr>
+            <a:r>
+              <a:t>💡 Buka di browser / salin source code: github.com/antonprafanto/mobile2026</a:t>
             </a:r>
           </a:p>
         </p:txBody>
@@ -14574,8 +16745,8 @@
         </p:nvSpPr>
         <p:spPr>
           <a:xfrm>
-            <a:off x="5669280" y="2176272"/>
-            <a:ext cx="5486400" cy="3977639"/>
+            <a:off x="5669280" y="2121408"/>
+            <a:ext cx="5486400" cy="3364992"/>
           </a:xfrm>
           <a:prstGeom prst="rect">
             <a:avLst/>
@@ -14589,7 +16760,7 @@
           <a:lstStyle/>
           <a:p>
             <a:pPr>
-              <a:defRPr sz="980">
+              <a:defRPr sz="919">
                 <a:solidFill>
                   <a:srgbClr val="F5F5F5"/>
                 </a:solidFill>
@@ -14642,6 +16813,142 @@
             <a:br/>
             <a:r>
               <a:t>}</a:t>
+            </a:r>
+          </a:p>
+        </p:txBody>
+      </p:sp>
+      <p:sp>
+        <p:nvSpPr>
+          <p:cNvPr id="15" name="Rectangle 14"/>
+          <p:cNvSpPr/>
+          <p:nvPr/>
+        </p:nvSpPr>
+        <p:spPr>
+          <a:xfrm>
+            <a:off x="5660136" y="5669280"/>
+            <a:ext cx="5608015" cy="548640"/>
+          </a:xfrm>
+          <a:prstGeom prst="rect">
+            <a:avLst/>
+          </a:prstGeom>
+          <a:solidFill>
+            <a:srgbClr val="000000"/>
+          </a:solidFill>
+          <a:ln>
+            <a:noFill/>
+          </a:ln>
+        </p:spPr>
+        <p:style>
+          <a:lnRef idx="1">
+            <a:schemeClr val="accent1"/>
+          </a:lnRef>
+          <a:fillRef idx="3">
+            <a:schemeClr val="accent1"/>
+          </a:fillRef>
+          <a:effectRef idx="2">
+            <a:schemeClr val="accent1"/>
+          </a:effectRef>
+          <a:fontRef idx="minor">
+            <a:schemeClr val="lt1"/>
+          </a:fontRef>
+        </p:style>
+        <p:txBody>
+          <a:bodyPr rtlCol="0" anchor="ctr"/>
+          <a:lstStyle/>
+          <a:p>
+            <a:pPr algn="ctr"/>
+          </a:p>
+        </p:txBody>
+      </p:sp>
+      <p:sp>
+        <p:nvSpPr>
+          <p:cNvPr id="16" name="Rectangle 15"/>
+          <p:cNvSpPr/>
+          <p:nvPr/>
+        </p:nvSpPr>
+        <p:spPr>
+          <a:xfrm>
+            <a:off x="5623560" y="5632704"/>
+            <a:ext cx="5608015" cy="548640"/>
+          </a:xfrm>
+          <a:prstGeom prst="rect">
+            <a:avLst/>
+          </a:prstGeom>
+          <a:solidFill>
+            <a:srgbClr val="FFE600"/>
+          </a:solidFill>
+          <a:ln w="25400">
+            <a:solidFill>
+              <a:srgbClr val="000000"/>
+            </a:solidFill>
+          </a:ln>
+        </p:spPr>
+        <p:style>
+          <a:lnRef idx="1">
+            <a:schemeClr val="accent1"/>
+          </a:lnRef>
+          <a:fillRef idx="3">
+            <a:schemeClr val="accent1"/>
+          </a:fillRef>
+          <a:effectRef idx="2">
+            <a:schemeClr val="accent1"/>
+          </a:effectRef>
+          <a:fontRef idx="minor">
+            <a:schemeClr val="lt1"/>
+          </a:fontRef>
+        </p:style>
+        <p:txBody>
+          <a:bodyPr rtlCol="0" anchor="ctr"/>
+          <a:lstStyle/>
+          <a:p>
+            <a:pPr algn="ctr"/>
+          </a:p>
+        </p:txBody>
+      </p:sp>
+      <p:sp>
+        <p:nvSpPr>
+          <p:cNvPr id="17" name="TextBox 16"/>
+          <p:cNvSpPr txBox="1"/>
+          <p:nvPr/>
+        </p:nvSpPr>
+        <p:spPr>
+          <a:xfrm>
+            <a:off x="5696712" y="5660136"/>
+            <a:ext cx="5461711" cy="493776"/>
+          </a:xfrm>
+          <a:prstGeom prst="rect">
+            <a:avLst/>
+          </a:prstGeom>
+          <a:noFill/>
+        </p:spPr>
+        <p:txBody>
+          <a:bodyPr wrap="square">
+            <a:spAutoFit/>
+          </a:bodyPr>
+          <a:lstStyle/>
+          <a:p>
+            <a:r>
+              <a:rPr sz="960" b="1">
+                <a:solidFill>
+                  <a:srgbClr val="000000"/>
+                </a:solidFill>
+                <a:latin typeface="Segoe UI"/>
+                <a:hlinkClick r:id="rId2"/>
+              </a:rPr>
+              <a:t>▶ BUKA KODE LENGKAP DI GITHUB (slide_03_filosofi_everything_is_widget.dart)</a:t>
+            </a:r>
+          </a:p>
+          <a:p>
+            <a:pPr>
+              <a:defRPr sz="760">
+                <a:solidFill>
+                  <a:srgbClr val="3C3C3C"/>
+                </a:solidFill>
+                <a:latin typeface="Segoe UI"/>
+              </a:defRPr>
+            </a:pPr>
+            <a:r>
+              <a:t>💡 Buka di browser / salin source code: github.com/antonprafanto/mobile2026</a:t>
             </a:r>
           </a:p>
         </p:txBody>
@@ -15232,8 +17539,8 @@
         </p:nvSpPr>
         <p:spPr>
           <a:xfrm>
-            <a:off x="5669280" y="2176272"/>
-            <a:ext cx="5486400" cy="3977639"/>
+            <a:off x="5669280" y="2121408"/>
+            <a:ext cx="5486400" cy="3364992"/>
           </a:xfrm>
           <a:prstGeom prst="rect">
             <a:avLst/>
@@ -15247,7 +17554,7 @@
           <a:lstStyle/>
           <a:p>
             <a:pPr>
-              <a:defRPr sz="980">
+              <a:defRPr sz="919">
                 <a:solidFill>
                   <a:srgbClr val="F5F5F5"/>
                 </a:solidFill>
@@ -15311,6 +17618,142 @@
             <a:br/>
             <a:r>
               <a:t>}</a:t>
+            </a:r>
+          </a:p>
+        </p:txBody>
+      </p:sp>
+      <p:sp>
+        <p:nvSpPr>
+          <p:cNvPr id="15" name="Rectangle 14"/>
+          <p:cNvSpPr/>
+          <p:nvPr/>
+        </p:nvSpPr>
+        <p:spPr>
+          <a:xfrm>
+            <a:off x="5660136" y="5669280"/>
+            <a:ext cx="5608015" cy="548640"/>
+          </a:xfrm>
+          <a:prstGeom prst="rect">
+            <a:avLst/>
+          </a:prstGeom>
+          <a:solidFill>
+            <a:srgbClr val="000000"/>
+          </a:solidFill>
+          <a:ln>
+            <a:noFill/>
+          </a:ln>
+        </p:spPr>
+        <p:style>
+          <a:lnRef idx="1">
+            <a:schemeClr val="accent1"/>
+          </a:lnRef>
+          <a:fillRef idx="3">
+            <a:schemeClr val="accent1"/>
+          </a:fillRef>
+          <a:effectRef idx="2">
+            <a:schemeClr val="accent1"/>
+          </a:effectRef>
+          <a:fontRef idx="minor">
+            <a:schemeClr val="lt1"/>
+          </a:fontRef>
+        </p:style>
+        <p:txBody>
+          <a:bodyPr rtlCol="0" anchor="ctr"/>
+          <a:lstStyle/>
+          <a:p>
+            <a:pPr algn="ctr"/>
+          </a:p>
+        </p:txBody>
+      </p:sp>
+      <p:sp>
+        <p:nvSpPr>
+          <p:cNvPr id="16" name="Rectangle 15"/>
+          <p:cNvSpPr/>
+          <p:nvPr/>
+        </p:nvSpPr>
+        <p:spPr>
+          <a:xfrm>
+            <a:off x="5623560" y="5632704"/>
+            <a:ext cx="5608015" cy="548640"/>
+          </a:xfrm>
+          <a:prstGeom prst="rect">
+            <a:avLst/>
+          </a:prstGeom>
+          <a:solidFill>
+            <a:srgbClr val="FFE600"/>
+          </a:solidFill>
+          <a:ln w="25400">
+            <a:solidFill>
+              <a:srgbClr val="000000"/>
+            </a:solidFill>
+          </a:ln>
+        </p:spPr>
+        <p:style>
+          <a:lnRef idx="1">
+            <a:schemeClr val="accent1"/>
+          </a:lnRef>
+          <a:fillRef idx="3">
+            <a:schemeClr val="accent1"/>
+          </a:fillRef>
+          <a:effectRef idx="2">
+            <a:schemeClr val="accent1"/>
+          </a:effectRef>
+          <a:fontRef idx="minor">
+            <a:schemeClr val="lt1"/>
+          </a:fontRef>
+        </p:style>
+        <p:txBody>
+          <a:bodyPr rtlCol="0" anchor="ctr"/>
+          <a:lstStyle/>
+          <a:p>
+            <a:pPr algn="ctr"/>
+          </a:p>
+        </p:txBody>
+      </p:sp>
+      <p:sp>
+        <p:nvSpPr>
+          <p:cNvPr id="17" name="TextBox 16"/>
+          <p:cNvSpPr txBox="1"/>
+          <p:nvPr/>
+        </p:nvSpPr>
+        <p:spPr>
+          <a:xfrm>
+            <a:off x="5696712" y="5660136"/>
+            <a:ext cx="5461711" cy="493776"/>
+          </a:xfrm>
+          <a:prstGeom prst="rect">
+            <a:avLst/>
+          </a:prstGeom>
+          <a:noFill/>
+        </p:spPr>
+        <p:txBody>
+          <a:bodyPr wrap="square">
+            <a:spAutoFit/>
+          </a:bodyPr>
+          <a:lstStyle/>
+          <a:p>
+            <a:r>
+              <a:rPr sz="960" b="1">
+                <a:solidFill>
+                  <a:srgbClr val="000000"/>
+                </a:solidFill>
+                <a:latin typeface="Segoe UI"/>
+                <a:hlinkClick r:id="rId2"/>
+              </a:rPr>
+              <a:t>▶ BUKA KODE LENGKAP DI GITHUB (slide_04_materialapp_dan_scaffold.dart)</a:t>
+            </a:r>
+          </a:p>
+          <a:p>
+            <a:pPr>
+              <a:defRPr sz="760">
+                <a:solidFill>
+                  <a:srgbClr val="3C3C3C"/>
+                </a:solidFill>
+                <a:latin typeface="Segoe UI"/>
+              </a:defRPr>
+            </a:pPr>
+            <a:r>
+              <a:t>💡 Buka di browser / salin source code: github.com/antonprafanto/mobile2026</a:t>
             </a:r>
           </a:p>
         </p:txBody>
@@ -15917,8 +18360,8 @@
         </p:nvSpPr>
         <p:spPr>
           <a:xfrm>
-            <a:off x="5669280" y="2176272"/>
-            <a:ext cx="5486400" cy="3977639"/>
+            <a:off x="5669280" y="2121408"/>
+            <a:ext cx="5486400" cy="3364992"/>
           </a:xfrm>
           <a:prstGeom prst="rect">
             <a:avLst/>
@@ -15932,7 +18375,7 @@
           <a:lstStyle/>
           <a:p>
             <a:pPr>
-              <a:defRPr sz="980">
+              <a:defRPr sz="919">
                 <a:solidFill>
                   <a:srgbClr val="F5F5F5"/>
                 </a:solidFill>
@@ -15979,6 +18422,142 @@
             <a:br/>
             <a:r>
               <a:t>// RenderBox mengukur koordinat piksel &amp; melukis warna.</a:t>
+            </a:r>
+          </a:p>
+        </p:txBody>
+      </p:sp>
+      <p:sp>
+        <p:nvSpPr>
+          <p:cNvPr id="15" name="Rectangle 14"/>
+          <p:cNvSpPr/>
+          <p:nvPr/>
+        </p:nvSpPr>
+        <p:spPr>
+          <a:xfrm>
+            <a:off x="5660136" y="5669280"/>
+            <a:ext cx="5608015" cy="548640"/>
+          </a:xfrm>
+          <a:prstGeom prst="rect">
+            <a:avLst/>
+          </a:prstGeom>
+          <a:solidFill>
+            <a:srgbClr val="000000"/>
+          </a:solidFill>
+          <a:ln>
+            <a:noFill/>
+          </a:ln>
+        </p:spPr>
+        <p:style>
+          <a:lnRef idx="1">
+            <a:schemeClr val="accent1"/>
+          </a:lnRef>
+          <a:fillRef idx="3">
+            <a:schemeClr val="accent1"/>
+          </a:fillRef>
+          <a:effectRef idx="2">
+            <a:schemeClr val="accent1"/>
+          </a:effectRef>
+          <a:fontRef idx="minor">
+            <a:schemeClr val="lt1"/>
+          </a:fontRef>
+        </p:style>
+        <p:txBody>
+          <a:bodyPr rtlCol="0" anchor="ctr"/>
+          <a:lstStyle/>
+          <a:p>
+            <a:pPr algn="ctr"/>
+          </a:p>
+        </p:txBody>
+      </p:sp>
+      <p:sp>
+        <p:nvSpPr>
+          <p:cNvPr id="16" name="Rectangle 15"/>
+          <p:cNvSpPr/>
+          <p:nvPr/>
+        </p:nvSpPr>
+        <p:spPr>
+          <a:xfrm>
+            <a:off x="5623560" y="5632704"/>
+            <a:ext cx="5608015" cy="548640"/>
+          </a:xfrm>
+          <a:prstGeom prst="rect">
+            <a:avLst/>
+          </a:prstGeom>
+          <a:solidFill>
+            <a:srgbClr val="FFE600"/>
+          </a:solidFill>
+          <a:ln w="25400">
+            <a:solidFill>
+              <a:srgbClr val="000000"/>
+            </a:solidFill>
+          </a:ln>
+        </p:spPr>
+        <p:style>
+          <a:lnRef idx="1">
+            <a:schemeClr val="accent1"/>
+          </a:lnRef>
+          <a:fillRef idx="3">
+            <a:schemeClr val="accent1"/>
+          </a:fillRef>
+          <a:effectRef idx="2">
+            <a:schemeClr val="accent1"/>
+          </a:effectRef>
+          <a:fontRef idx="minor">
+            <a:schemeClr val="lt1"/>
+          </a:fontRef>
+        </p:style>
+        <p:txBody>
+          <a:bodyPr rtlCol="0" anchor="ctr"/>
+          <a:lstStyle/>
+          <a:p>
+            <a:pPr algn="ctr"/>
+          </a:p>
+        </p:txBody>
+      </p:sp>
+      <p:sp>
+        <p:nvSpPr>
+          <p:cNvPr id="17" name="TextBox 16"/>
+          <p:cNvSpPr txBox="1"/>
+          <p:nvPr/>
+        </p:nvSpPr>
+        <p:spPr>
+          <a:xfrm>
+            <a:off x="5696712" y="5660136"/>
+            <a:ext cx="5461711" cy="493776"/>
+          </a:xfrm>
+          <a:prstGeom prst="rect">
+            <a:avLst/>
+          </a:prstGeom>
+          <a:noFill/>
+        </p:spPr>
+        <p:txBody>
+          <a:bodyPr wrap="square">
+            <a:spAutoFit/>
+          </a:bodyPr>
+          <a:lstStyle/>
+          <a:p>
+            <a:r>
+              <a:rPr sz="960" b="1">
+                <a:solidFill>
+                  <a:srgbClr val="000000"/>
+                </a:solidFill>
+                <a:latin typeface="Segoe UI"/>
+                <a:hlinkClick r:id="rId2"/>
+              </a:rPr>
+              <a:t>▶ BUKA KODE LENGKAP DI GITHUB (slide_05_arsitektur_the_three_trees.dart)</a:t>
+            </a:r>
+          </a:p>
+          <a:p>
+            <a:pPr>
+              <a:defRPr sz="760">
+                <a:solidFill>
+                  <a:srgbClr val="3C3C3C"/>
+                </a:solidFill>
+                <a:latin typeface="Segoe UI"/>
+              </a:defRPr>
+            </a:pPr>
+            <a:r>
+              <a:t>💡 Buka di browser / salin source code: github.com/antonprafanto/mobile2026</a:t>
             </a:r>
           </a:p>
         </p:txBody>
@@ -16585,8 +19164,8 @@
         </p:nvSpPr>
         <p:spPr>
           <a:xfrm>
-            <a:off x="5669280" y="2176272"/>
-            <a:ext cx="5486400" cy="3977639"/>
+            <a:off x="5669280" y="2121408"/>
+            <a:ext cx="5486400" cy="3364992"/>
           </a:xfrm>
           <a:prstGeom prst="rect">
             <a:avLst/>
@@ -16600,7 +19179,7 @@
           <a:lstStyle/>
           <a:p>
             <a:pPr>
-              <a:defRPr sz="980">
+              <a:defRPr sz="919">
                 <a:solidFill>
                   <a:srgbClr val="F5F5F5"/>
                 </a:solidFill>
@@ -16670,6 +19249,142 @@
             <a:br/>
             <a:r>
               <a:t>}</a:t>
+            </a:r>
+          </a:p>
+        </p:txBody>
+      </p:sp>
+      <p:sp>
+        <p:nvSpPr>
+          <p:cNvPr id="15" name="Rectangle 14"/>
+          <p:cNvSpPr/>
+          <p:nvPr/>
+        </p:nvSpPr>
+        <p:spPr>
+          <a:xfrm>
+            <a:off x="5660136" y="5669280"/>
+            <a:ext cx="5608015" cy="548640"/>
+          </a:xfrm>
+          <a:prstGeom prst="rect">
+            <a:avLst/>
+          </a:prstGeom>
+          <a:solidFill>
+            <a:srgbClr val="000000"/>
+          </a:solidFill>
+          <a:ln>
+            <a:noFill/>
+          </a:ln>
+        </p:spPr>
+        <p:style>
+          <a:lnRef idx="1">
+            <a:schemeClr val="accent1"/>
+          </a:lnRef>
+          <a:fillRef idx="3">
+            <a:schemeClr val="accent1"/>
+          </a:fillRef>
+          <a:effectRef idx="2">
+            <a:schemeClr val="accent1"/>
+          </a:effectRef>
+          <a:fontRef idx="minor">
+            <a:schemeClr val="lt1"/>
+          </a:fontRef>
+        </p:style>
+        <p:txBody>
+          <a:bodyPr rtlCol="0" anchor="ctr"/>
+          <a:lstStyle/>
+          <a:p>
+            <a:pPr algn="ctr"/>
+          </a:p>
+        </p:txBody>
+      </p:sp>
+      <p:sp>
+        <p:nvSpPr>
+          <p:cNvPr id="16" name="Rectangle 15"/>
+          <p:cNvSpPr/>
+          <p:nvPr/>
+        </p:nvSpPr>
+        <p:spPr>
+          <a:xfrm>
+            <a:off x="5623560" y="5632704"/>
+            <a:ext cx="5608015" cy="548640"/>
+          </a:xfrm>
+          <a:prstGeom prst="rect">
+            <a:avLst/>
+          </a:prstGeom>
+          <a:solidFill>
+            <a:srgbClr val="FFE600"/>
+          </a:solidFill>
+          <a:ln w="25400">
+            <a:solidFill>
+              <a:srgbClr val="000000"/>
+            </a:solidFill>
+          </a:ln>
+        </p:spPr>
+        <p:style>
+          <a:lnRef idx="1">
+            <a:schemeClr val="accent1"/>
+          </a:lnRef>
+          <a:fillRef idx="3">
+            <a:schemeClr val="accent1"/>
+          </a:fillRef>
+          <a:effectRef idx="2">
+            <a:schemeClr val="accent1"/>
+          </a:effectRef>
+          <a:fontRef idx="minor">
+            <a:schemeClr val="lt1"/>
+          </a:fontRef>
+        </p:style>
+        <p:txBody>
+          <a:bodyPr rtlCol="0" anchor="ctr"/>
+          <a:lstStyle/>
+          <a:p>
+            <a:pPr algn="ctr"/>
+          </a:p>
+        </p:txBody>
+      </p:sp>
+      <p:sp>
+        <p:nvSpPr>
+          <p:cNvPr id="17" name="TextBox 16"/>
+          <p:cNvSpPr txBox="1"/>
+          <p:nvPr/>
+        </p:nvSpPr>
+        <p:spPr>
+          <a:xfrm>
+            <a:off x="5696712" y="5660136"/>
+            <a:ext cx="5461711" cy="493776"/>
+          </a:xfrm>
+          <a:prstGeom prst="rect">
+            <a:avLst/>
+          </a:prstGeom>
+          <a:noFill/>
+        </p:spPr>
+        <p:txBody>
+          <a:bodyPr wrap="square">
+            <a:spAutoFit/>
+          </a:bodyPr>
+          <a:lstStyle/>
+          <a:p>
+            <a:r>
+              <a:rPr sz="960" b="1">
+                <a:solidFill>
+                  <a:srgbClr val="000000"/>
+                </a:solidFill>
+                <a:latin typeface="Segoe UI"/>
+                <a:hlinkClick r:id="rId2"/>
+              </a:rPr>
+              <a:t>▶ BUKA KODE LENGKAP DI GITHUB (slide_06_stateless_vs_stateful.dart)</a:t>
+            </a:r>
+          </a:p>
+          <a:p>
+            <a:pPr>
+              <a:defRPr sz="760">
+                <a:solidFill>
+                  <a:srgbClr val="3C3C3C"/>
+                </a:solidFill>
+                <a:latin typeface="Segoe UI"/>
+              </a:defRPr>
+            </a:pPr>
+            <a:r>
+              <a:t>💡 Buka di browser / salin source code: github.com/antonprafanto/mobile2026</a:t>
             </a:r>
           </a:p>
         </p:txBody>
@@ -17260,8 +19975,8 @@
         </p:nvSpPr>
         <p:spPr>
           <a:xfrm>
-            <a:off x="5669280" y="2176272"/>
-            <a:ext cx="5486400" cy="3977639"/>
+            <a:off x="5669280" y="2121408"/>
+            <a:ext cx="5486400" cy="3364992"/>
           </a:xfrm>
           <a:prstGeom prst="rect">
             <a:avLst/>
@@ -17275,7 +19990,7 @@
           <a:lstStyle/>
           <a:p>
             <a:pPr>
-              <a:defRPr sz="980">
+              <a:defRPr sz="919">
                 <a:solidFill>
                   <a:srgbClr val="F5F5F5"/>
                 </a:solidFill>
@@ -17351,6 +20066,142 @@
             <a:br/>
             <a:r>
               <a:t>}</a:t>
+            </a:r>
+          </a:p>
+        </p:txBody>
+      </p:sp>
+      <p:sp>
+        <p:nvSpPr>
+          <p:cNvPr id="15" name="Rectangle 14"/>
+          <p:cNvSpPr/>
+          <p:nvPr/>
+        </p:nvSpPr>
+        <p:spPr>
+          <a:xfrm>
+            <a:off x="5660136" y="5669280"/>
+            <a:ext cx="5608015" cy="548640"/>
+          </a:xfrm>
+          <a:prstGeom prst="rect">
+            <a:avLst/>
+          </a:prstGeom>
+          <a:solidFill>
+            <a:srgbClr val="000000"/>
+          </a:solidFill>
+          <a:ln>
+            <a:noFill/>
+          </a:ln>
+        </p:spPr>
+        <p:style>
+          <a:lnRef idx="1">
+            <a:schemeClr val="accent1"/>
+          </a:lnRef>
+          <a:fillRef idx="3">
+            <a:schemeClr val="accent1"/>
+          </a:fillRef>
+          <a:effectRef idx="2">
+            <a:schemeClr val="accent1"/>
+          </a:effectRef>
+          <a:fontRef idx="minor">
+            <a:schemeClr val="lt1"/>
+          </a:fontRef>
+        </p:style>
+        <p:txBody>
+          <a:bodyPr rtlCol="0" anchor="ctr"/>
+          <a:lstStyle/>
+          <a:p>
+            <a:pPr algn="ctr"/>
+          </a:p>
+        </p:txBody>
+      </p:sp>
+      <p:sp>
+        <p:nvSpPr>
+          <p:cNvPr id="16" name="Rectangle 15"/>
+          <p:cNvSpPr/>
+          <p:nvPr/>
+        </p:nvSpPr>
+        <p:spPr>
+          <a:xfrm>
+            <a:off x="5623560" y="5632704"/>
+            <a:ext cx="5608015" cy="548640"/>
+          </a:xfrm>
+          <a:prstGeom prst="rect">
+            <a:avLst/>
+          </a:prstGeom>
+          <a:solidFill>
+            <a:srgbClr val="FFE600"/>
+          </a:solidFill>
+          <a:ln w="25400">
+            <a:solidFill>
+              <a:srgbClr val="000000"/>
+            </a:solidFill>
+          </a:ln>
+        </p:spPr>
+        <p:style>
+          <a:lnRef idx="1">
+            <a:schemeClr val="accent1"/>
+          </a:lnRef>
+          <a:fillRef idx="3">
+            <a:schemeClr val="accent1"/>
+          </a:fillRef>
+          <a:effectRef idx="2">
+            <a:schemeClr val="accent1"/>
+          </a:effectRef>
+          <a:fontRef idx="minor">
+            <a:schemeClr val="lt1"/>
+          </a:fontRef>
+        </p:style>
+        <p:txBody>
+          <a:bodyPr rtlCol="0" anchor="ctr"/>
+          <a:lstStyle/>
+          <a:p>
+            <a:pPr algn="ctr"/>
+          </a:p>
+        </p:txBody>
+      </p:sp>
+      <p:sp>
+        <p:nvSpPr>
+          <p:cNvPr id="17" name="TextBox 16"/>
+          <p:cNvSpPr txBox="1"/>
+          <p:nvPr/>
+        </p:nvSpPr>
+        <p:spPr>
+          <a:xfrm>
+            <a:off x="5696712" y="5660136"/>
+            <a:ext cx="5461711" cy="493776"/>
+          </a:xfrm>
+          <a:prstGeom prst="rect">
+            <a:avLst/>
+          </a:prstGeom>
+          <a:noFill/>
+        </p:spPr>
+        <p:txBody>
+          <a:bodyPr wrap="square">
+            <a:spAutoFit/>
+          </a:bodyPr>
+          <a:lstStyle/>
+          <a:p>
+            <a:r>
+              <a:rPr sz="960" b="1">
+                <a:solidFill>
+                  <a:srgbClr val="000000"/>
+                </a:solidFill>
+                <a:latin typeface="Segoe UI"/>
+                <a:hlinkClick r:id="rId2"/>
+              </a:rPr>
+              <a:t>▶ BUKA KODE LENGKAP DI GITHUB (slide_07_siklus_hidup_stateful.dart)</a:t>
+            </a:r>
+          </a:p>
+          <a:p>
+            <a:pPr>
+              <a:defRPr sz="760">
+                <a:solidFill>
+                  <a:srgbClr val="3C3C3C"/>
+                </a:solidFill>
+                <a:latin typeface="Segoe UI"/>
+              </a:defRPr>
+            </a:pPr>
+            <a:r>
+              <a:t>💡 Buka di browser / salin source code: github.com/antonprafanto/mobile2026</a:t>
             </a:r>
           </a:p>
         </p:txBody>
@@ -17957,8 +20808,8 @@
         </p:nvSpPr>
         <p:spPr>
           <a:xfrm>
-            <a:off x="5669280" y="2176272"/>
-            <a:ext cx="5486400" cy="3977639"/>
+            <a:off x="5669280" y="2121408"/>
+            <a:ext cx="5486400" cy="3364992"/>
           </a:xfrm>
           <a:prstGeom prst="rect">
             <a:avLst/>
@@ -17972,7 +20823,7 @@
           <a:lstStyle/>
           <a:p>
             <a:pPr>
-              <a:defRPr sz="980">
+              <a:defRPr sz="919">
                 <a:solidFill>
                   <a:srgbClr val="F5F5F5"/>
                 </a:solidFill>
@@ -18017,6 +20868,142 @@
             <a:br/>
             <a:r>
               <a:t>)</a:t>
+            </a:r>
+          </a:p>
+        </p:txBody>
+      </p:sp>
+      <p:sp>
+        <p:nvSpPr>
+          <p:cNvPr id="15" name="Rectangle 14"/>
+          <p:cNvSpPr/>
+          <p:nvPr/>
+        </p:nvSpPr>
+        <p:spPr>
+          <a:xfrm>
+            <a:off x="5660136" y="5669280"/>
+            <a:ext cx="5608015" cy="548640"/>
+          </a:xfrm>
+          <a:prstGeom prst="rect">
+            <a:avLst/>
+          </a:prstGeom>
+          <a:solidFill>
+            <a:srgbClr val="000000"/>
+          </a:solidFill>
+          <a:ln>
+            <a:noFill/>
+          </a:ln>
+        </p:spPr>
+        <p:style>
+          <a:lnRef idx="1">
+            <a:schemeClr val="accent1"/>
+          </a:lnRef>
+          <a:fillRef idx="3">
+            <a:schemeClr val="accent1"/>
+          </a:fillRef>
+          <a:effectRef idx="2">
+            <a:schemeClr val="accent1"/>
+          </a:effectRef>
+          <a:fontRef idx="minor">
+            <a:schemeClr val="lt1"/>
+          </a:fontRef>
+        </p:style>
+        <p:txBody>
+          <a:bodyPr rtlCol="0" anchor="ctr"/>
+          <a:lstStyle/>
+          <a:p>
+            <a:pPr algn="ctr"/>
+          </a:p>
+        </p:txBody>
+      </p:sp>
+      <p:sp>
+        <p:nvSpPr>
+          <p:cNvPr id="16" name="Rectangle 15"/>
+          <p:cNvSpPr/>
+          <p:nvPr/>
+        </p:nvSpPr>
+        <p:spPr>
+          <a:xfrm>
+            <a:off x="5623560" y="5632704"/>
+            <a:ext cx="5608015" cy="548640"/>
+          </a:xfrm>
+          <a:prstGeom prst="rect">
+            <a:avLst/>
+          </a:prstGeom>
+          <a:solidFill>
+            <a:srgbClr val="FFE600"/>
+          </a:solidFill>
+          <a:ln w="25400">
+            <a:solidFill>
+              <a:srgbClr val="000000"/>
+            </a:solidFill>
+          </a:ln>
+        </p:spPr>
+        <p:style>
+          <a:lnRef idx="1">
+            <a:schemeClr val="accent1"/>
+          </a:lnRef>
+          <a:fillRef idx="3">
+            <a:schemeClr val="accent1"/>
+          </a:fillRef>
+          <a:effectRef idx="2">
+            <a:schemeClr val="accent1"/>
+          </a:effectRef>
+          <a:fontRef idx="minor">
+            <a:schemeClr val="lt1"/>
+          </a:fontRef>
+        </p:style>
+        <p:txBody>
+          <a:bodyPr rtlCol="0" anchor="ctr"/>
+          <a:lstStyle/>
+          <a:p>
+            <a:pPr algn="ctr"/>
+          </a:p>
+        </p:txBody>
+      </p:sp>
+      <p:sp>
+        <p:nvSpPr>
+          <p:cNvPr id="17" name="TextBox 16"/>
+          <p:cNvSpPr txBox="1"/>
+          <p:nvPr/>
+        </p:nvSpPr>
+        <p:spPr>
+          <a:xfrm>
+            <a:off x="5696712" y="5660136"/>
+            <a:ext cx="5461711" cy="493776"/>
+          </a:xfrm>
+          <a:prstGeom prst="rect">
+            <a:avLst/>
+          </a:prstGeom>
+          <a:noFill/>
+        </p:spPr>
+        <p:txBody>
+          <a:bodyPr wrap="square">
+            <a:spAutoFit/>
+          </a:bodyPr>
+          <a:lstStyle/>
+          <a:p>
+            <a:r>
+              <a:rPr sz="960" b="1">
+                <a:solidFill>
+                  <a:srgbClr val="000000"/>
+                </a:solidFill>
+                <a:latin typeface="Segoe UI"/>
+                <a:hlinkClick r:id="rId2"/>
+              </a:rPr>
+              <a:t>▶ BUKA KODE LENGKAP DI GITHUB (slide_08_hukum_box_constraints.dart)</a:t>
+            </a:r>
+          </a:p>
+          <a:p>
+            <a:pPr>
+              <a:defRPr sz="760">
+                <a:solidFill>
+                  <a:srgbClr val="3C3C3C"/>
+                </a:solidFill>
+                <a:latin typeface="Segoe UI"/>
+              </a:defRPr>
+            </a:pPr>
+            <a:r>
+              <a:t>💡 Buka di browser / salin source code: github.com/antonprafanto/mobile2026</a:t>
             </a:r>
           </a:p>
         </p:txBody>
@@ -18607,8 +21594,8 @@
         </p:nvSpPr>
         <p:spPr>
           <a:xfrm>
-            <a:off x="5669280" y="2176272"/>
-            <a:ext cx="5486400" cy="3977639"/>
+            <a:off x="5669280" y="2121408"/>
+            <a:ext cx="5486400" cy="3364992"/>
           </a:xfrm>
           <a:prstGeom prst="rect">
             <a:avLst/>
@@ -18622,7 +21609,7 @@
           <a:lstStyle/>
           <a:p>
             <a:pPr>
-              <a:defRPr sz="980">
+              <a:defRPr sz="919">
                 <a:solidFill>
                   <a:srgbClr val="F5F5F5"/>
                 </a:solidFill>
@@ -18688,6 +21675,142 @@
             <a:br/>
             <a:r>
               <a:t>}</a:t>
+            </a:r>
+          </a:p>
+        </p:txBody>
+      </p:sp>
+      <p:sp>
+        <p:nvSpPr>
+          <p:cNvPr id="15" name="Rectangle 14"/>
+          <p:cNvSpPr/>
+          <p:nvPr/>
+        </p:nvSpPr>
+        <p:spPr>
+          <a:xfrm>
+            <a:off x="5660136" y="5669280"/>
+            <a:ext cx="5608015" cy="548640"/>
+          </a:xfrm>
+          <a:prstGeom prst="rect">
+            <a:avLst/>
+          </a:prstGeom>
+          <a:solidFill>
+            <a:srgbClr val="000000"/>
+          </a:solidFill>
+          <a:ln>
+            <a:noFill/>
+          </a:ln>
+        </p:spPr>
+        <p:style>
+          <a:lnRef idx="1">
+            <a:schemeClr val="accent1"/>
+          </a:lnRef>
+          <a:fillRef idx="3">
+            <a:schemeClr val="accent1"/>
+          </a:fillRef>
+          <a:effectRef idx="2">
+            <a:schemeClr val="accent1"/>
+          </a:effectRef>
+          <a:fontRef idx="minor">
+            <a:schemeClr val="lt1"/>
+          </a:fontRef>
+        </p:style>
+        <p:txBody>
+          <a:bodyPr rtlCol="0" anchor="ctr"/>
+          <a:lstStyle/>
+          <a:p>
+            <a:pPr algn="ctr"/>
+          </a:p>
+        </p:txBody>
+      </p:sp>
+      <p:sp>
+        <p:nvSpPr>
+          <p:cNvPr id="16" name="Rectangle 15"/>
+          <p:cNvSpPr/>
+          <p:nvPr/>
+        </p:nvSpPr>
+        <p:spPr>
+          <a:xfrm>
+            <a:off x="5623560" y="5632704"/>
+            <a:ext cx="5608015" cy="548640"/>
+          </a:xfrm>
+          <a:prstGeom prst="rect">
+            <a:avLst/>
+          </a:prstGeom>
+          <a:solidFill>
+            <a:srgbClr val="FFE600"/>
+          </a:solidFill>
+          <a:ln w="25400">
+            <a:solidFill>
+              <a:srgbClr val="000000"/>
+            </a:solidFill>
+          </a:ln>
+        </p:spPr>
+        <p:style>
+          <a:lnRef idx="1">
+            <a:schemeClr val="accent1"/>
+          </a:lnRef>
+          <a:fillRef idx="3">
+            <a:schemeClr val="accent1"/>
+          </a:fillRef>
+          <a:effectRef idx="2">
+            <a:schemeClr val="accent1"/>
+          </a:effectRef>
+          <a:fontRef idx="minor">
+            <a:schemeClr val="lt1"/>
+          </a:fontRef>
+        </p:style>
+        <p:txBody>
+          <a:bodyPr rtlCol="0" anchor="ctr"/>
+          <a:lstStyle/>
+          <a:p>
+            <a:pPr algn="ctr"/>
+          </a:p>
+        </p:txBody>
+      </p:sp>
+      <p:sp>
+        <p:nvSpPr>
+          <p:cNvPr id="17" name="TextBox 16"/>
+          <p:cNvSpPr txBox="1"/>
+          <p:nvPr/>
+        </p:nvSpPr>
+        <p:spPr>
+          <a:xfrm>
+            <a:off x="5696712" y="5660136"/>
+            <a:ext cx="5461711" cy="493776"/>
+          </a:xfrm>
+          <a:prstGeom prst="rect">
+            <a:avLst/>
+          </a:prstGeom>
+          <a:noFill/>
+        </p:spPr>
+        <p:txBody>
+          <a:bodyPr wrap="square">
+            <a:spAutoFit/>
+          </a:bodyPr>
+          <a:lstStyle/>
+          <a:p>
+            <a:r>
+              <a:rPr sz="960" b="1">
+                <a:solidFill>
+                  <a:srgbClr val="000000"/>
+                </a:solidFill>
+                <a:latin typeface="Segoe UI"/>
+                <a:hlinkClick r:id="rId2"/>
+              </a:rPr>
+              <a:t>▶ BUKA KODE LENGKAP DI GITHUB (slide_09_penyelamat_layar_safearea.dart)</a:t>
+            </a:r>
+          </a:p>
+          <a:p>
+            <a:pPr>
+              <a:defRPr sz="760">
+                <a:solidFill>
+                  <a:srgbClr val="3C3C3C"/>
+                </a:solidFill>
+                <a:latin typeface="Segoe UI"/>
+              </a:defRPr>
+            </a:pPr>
+            <a:r>
+              <a:t>💡 Buka di browser / salin source code: github.com/antonprafanto/mobile2026</a:t>
             </a:r>
           </a:p>
         </p:txBody>

</xml_diff>